<commit_message>
Apply review fixes: business model, research, threat model, decision log, stress test
</commit_message>
<xml_diff>
--- a/docs/Munim_Pitch.pptx
+++ b/docs/Munim_Pitch.pptx
@@ -185,7 +185,7 @@
                     <c:v>Keep every offer</c:v>
                   </c:pt>
                   <c:pt idx="1">
-                    <c:v>Shop's own data</c:v>
+                    <c:v>Shop's own group</c:v>
                   </c:pt>
                   <c:pt idx="2">
                     <c:v>Munim, pooled</c:v>
@@ -2208,7 +2208,7 @@
         <p:spPr>
           <a:xfrm>
             <a:off x="7772400" y="1325880"/>
-            <a:ext cx="1828800" cy="201168"/>
+            <a:ext cx="2743200" cy="201168"/>
           </a:xfrm>
           <a:prstGeom prst="rect">
             <a:avLst/>
@@ -2277,7 +2277,7 @@
                 <a:ea typeface="Cambria" pitchFamily="34" charset="-122"/>
                 <a:cs typeface="Cambria" pitchFamily="34" charset="-120"/>
               </a:rPr>
-              <a:t>Manzoori chahiye: 32 grahakon ko ₹250+ par ₹15 cashback, zyada se zyada ₹480.</a:t>
+              <a:t>32 grahakon ko ₹250+ ke bill par ₹15 cashback bhejein? Kharcha ₹480 tak.</a:t>
             </a:r>
             <a:endParaRPr lang="en-US" sz="1700" dirty="0"/>
           </a:p>
@@ -2319,7 +2319,7 @@
                 <a:ea typeface="Calibri" pitchFamily="34" charset="-122"/>
                 <a:cs typeface="Calibri" pitchFamily="34" charset="-120"/>
               </a:rPr>
-              <a:t>Needs your OK: ₹15 cashback on ₹250+ bills for 32 customers, up to ₹480.</a:t>
+              <a:t>Send ₹15 cashback on ₹250+ bills to 32 customers? It costs up to ₹480.</a:t>
             </a:r>
             <a:endParaRPr lang="en-US" sz="1100" dirty="0"/>
           </a:p>
@@ -2555,27 +2555,27 @@
         </p:nvSpPr>
         <p:spPr>
           <a:xfrm>
-            <a:off x="640080" y="5623560"/>
-            <a:ext cx="8229600" cy="274320"/>
-          </a:xfrm>
-          <a:prstGeom prst="rect">
-            <a:avLst/>
-          </a:prstGeom>
-          <a:noFill/>
-          <a:ln/>
-        </p:spPr>
-        <p:txBody>
-          <a:bodyPr wrap="square" lIns="0" tIns="0" rIns="0" bIns="0" rtlCol="0" anchor="t"/>
-          <a:lstStyle/>
-          <a:p>
-            <a:pPr algn="l" indent="0" marL="0">
-              <a:lnSpc>
-                <a:spcPct val="110000"/>
-              </a:lnSpc>
-              <a:buNone/>
-            </a:pPr>
-            <a:r>
-              <a:rPr lang="en-US" sz="1300" dirty="0">
+            <a:off x="640080" y="5650992"/>
+            <a:ext cx="10515600" cy="320040"/>
+          </a:xfrm>
+          <a:prstGeom prst="rect">
+            <a:avLst/>
+          </a:prstGeom>
+          <a:noFill/>
+          <a:ln/>
+        </p:spPr>
+        <p:txBody>
+          <a:bodyPr wrap="square" lIns="0" tIns="0" rIns="0" bIns="0" rtlCol="0" anchor="t"/>
+          <a:lstStyle/>
+          <a:p>
+            <a:pPr algn="l" indent="0" marL="0">
+              <a:lnSpc>
+                <a:spcPct val="110000"/>
+              </a:lnSpc>
+              <a:buNone/>
+            </a:pPr>
+            <a:r>
+              <a:rPr lang="en-US" sz="1500" b="1" dirty="0">
                 <a:solidFill>
                   <a:srgbClr val="A9A9B2"/>
                 </a:solidFill>
@@ -2583,9 +2583,101 @@
                 <a:ea typeface="Calibri" pitchFamily="34" charset="-122"/>
                 <a:cs typeface="Calibri" pitchFamily="34" charset="-120"/>
               </a:rPr>
-              <a:t>github.com/saksham869/munim     ·     Live demo: saksham869.github.io/munim</a:t>
-            </a:r>
-            <a:endParaRPr lang="en-US" sz="1300" dirty="0"/>
+              <a:t>Live demo  </a:t>
+            </a:r>
+            <a:pPr algn="l" indent="0" marL="0">
+              <a:lnSpc>
+                <a:spcPct val="110000"/>
+              </a:lnSpc>
+              <a:buNone/>
+            </a:pPr>
+            <a:r>
+              <a:rPr lang="en-US" sz="1500" b="1" u="sng" dirty="0">
+                <a:solidFill>
+                  <a:srgbClr val="E3A72F"/>
+                </a:solidFill>
+                <a:uFill>
+                  <a:solidFill>
+                    <a:srgbClr val="E3A72F"/>
+                  </a:solidFill>
+                </a:uFill>
+                <a:latin typeface="Calibri" pitchFamily="34" charset="0"/>
+                <a:ea typeface="Calibri" pitchFamily="34" charset="-122"/>
+                <a:cs typeface="Calibri" pitchFamily="34" charset="-120"/>
+                <a:hlinkClick r:id="rId1" invalidUrl="" action="" tgtFrame="" tooltip="https://saksham869.github.io/munim/" history="1" highlightClick="0" endSnd="0">
+                  <a:extLst>
+                    <a:ext uri="{A12FA001-AC4F-418D-AE19-62706E023703}">
+                      <ahyp:hlinkClr xmlns:ahyp="http://schemas.microsoft.com/office/drawing/2018/hyperlinkcolor" val="tx"/>
+                    </a:ext>
+                  </a:extLst>
+                </a:hlinkClick>
+              </a:rPr>
+              <a:t>saksham869.github.io/munim</a:t>
+            </a:r>
+            <a:pPr algn="l" indent="0" marL="0">
+              <a:lnSpc>
+                <a:spcPct val="110000"/>
+              </a:lnSpc>
+              <a:buNone/>
+            </a:pPr>
+            <a:r>
+              <a:rPr lang="en-US" sz="1500" dirty="0">
+                <a:solidFill>
+                  <a:srgbClr val="000000"/>
+                </a:solidFill>
+                <a:latin typeface="Calibri" pitchFamily="34" charset="0"/>
+                <a:ea typeface="Calibri" pitchFamily="34" charset="-122"/>
+                <a:cs typeface="Calibri" pitchFamily="34" charset="-120"/>
+              </a:rPr>
+              <a:t>        </a:t>
+            </a:r>
+            <a:pPr algn="l" indent="0" marL="0">
+              <a:lnSpc>
+                <a:spcPct val="110000"/>
+              </a:lnSpc>
+              <a:buNone/>
+            </a:pPr>
+            <a:r>
+              <a:rPr lang="en-US" sz="1500" b="1" dirty="0">
+                <a:solidFill>
+                  <a:srgbClr val="A9A9B2"/>
+                </a:solidFill>
+                <a:latin typeface="Calibri" pitchFamily="34" charset="0"/>
+                <a:ea typeface="Calibri" pitchFamily="34" charset="-122"/>
+                <a:cs typeface="Calibri" pitchFamily="34" charset="-120"/>
+              </a:rPr>
+              <a:t>Code  </a:t>
+            </a:r>
+            <a:pPr algn="l" indent="0" marL="0">
+              <a:lnSpc>
+                <a:spcPct val="110000"/>
+              </a:lnSpc>
+              <a:buNone/>
+            </a:pPr>
+            <a:r>
+              <a:rPr lang="en-US" sz="1500" b="1" u="sng" dirty="0">
+                <a:solidFill>
+                  <a:srgbClr val="E3A72F"/>
+                </a:solidFill>
+                <a:uFill>
+                  <a:solidFill>
+                    <a:srgbClr val="E3A72F"/>
+                  </a:solidFill>
+                </a:uFill>
+                <a:latin typeface="Calibri" pitchFamily="34" charset="0"/>
+                <a:ea typeface="Calibri" pitchFamily="34" charset="-122"/>
+                <a:cs typeface="Calibri" pitchFamily="34" charset="-120"/>
+                <a:hlinkClick r:id="rId2" invalidUrl="" action="" tgtFrame="" tooltip="https://github.com/saksham869/munim" history="1" highlightClick="0" endSnd="0">
+                  <a:extLst>
+                    <a:ext uri="{A12FA001-AC4F-418D-AE19-62706E023703}">
+                      <ahyp:hlinkClr xmlns:ahyp="http://schemas.microsoft.com/office/drawing/2018/hyperlinkcolor" val="tx"/>
+                    </a:ext>
+                  </a:extLst>
+                </a:hlinkClick>
+              </a:rPr>
+              <a:t>github.com/saksham869/munim</a:t>
+            </a:r>
+            <a:endParaRPr lang="en-US" sz="1500" dirty="0"/>
           </a:p>
         </p:txBody>
       </p:sp>
@@ -2657,7 +2749,7 @@
                 <a:ea typeface="Calibri" pitchFamily="34" charset="-122"/>
                 <a:cs typeface="Calibri" pitchFamily="34" charset="-120"/>
               </a:rPr>
-              <a:t>BUSINESS MODEL</a:t>
+              <a:t>BUSINESS MODEL (PROPOSED)</a:t>
             </a:r>
             <a:endParaRPr lang="en-US" sz="1100" dirty="0"/>
           </a:p>
@@ -2699,7 +2791,7 @@
                 <a:ea typeface="Cambria" pitchFamily="34" charset="-122"/>
                 <a:cs typeface="Cambria" pitchFamily="34" charset="-120"/>
               </a:rPr>
-              <a:t>Sold with Pi Agents. Paid when it works</a:t>
+              <a:t>Part of Pi Agents, so agent-run offers are safe to sell</a:t>
             </a:r>
             <a:endParaRPr lang="en-US" sz="3000" dirty="0"/>
           </a:p>
@@ -2714,7 +2806,7 @@
         <p:spPr>
           <a:xfrm>
             <a:off x="548640" y="6419088"/>
-            <a:ext cx="7315200" cy="228600"/>
+            <a:ext cx="5852160" cy="228600"/>
           </a:xfrm>
           <a:prstGeom prst="rect">
             <a:avLst/>
@@ -2750,6 +2842,77 @@
       <p:sp>
         <p:nvSpPr>
           <p:cNvPr id="5" name="Text 3"/>
+          <p:cNvSpPr txBox="1"/>
+          <p:nvPr/>
+        </p:nvSpPr>
+        <p:spPr>
+          <a:xfrm>
+            <a:off x="6583680" y="6419088"/>
+            <a:ext cx="4510735" cy="228600"/>
+          </a:xfrm>
+          <a:prstGeom prst="rect">
+            <a:avLst/>
+          </a:prstGeom>
+          <a:noFill/>
+          <a:ln/>
+        </p:spPr>
+        <p:txBody>
+          <a:bodyPr wrap="square" lIns="0" tIns="0" rIns="0" bIns="0" rtlCol="0" anchor="t"/>
+          <a:lstStyle/>
+          <a:p>
+            <a:pPr algn="r" indent="0" marL="0">
+              <a:lnSpc>
+                <a:spcPct val="110000"/>
+              </a:lnSpc>
+              <a:buNone/>
+            </a:pPr>
+            <a:r>
+              <a:rPr lang="en-US" sz="900" b="1" dirty="0">
+                <a:solidFill>
+                  <a:srgbClr val="6B6B73"/>
+                </a:solidFill>
+                <a:latin typeface="Calibri" pitchFamily="34" charset="0"/>
+                <a:ea typeface="Calibri" pitchFamily="34" charset="-122"/>
+                <a:cs typeface="Calibri" pitchFamily="34" charset="-120"/>
+              </a:rPr>
+              <a:t>Live demo  </a:t>
+            </a:r>
+            <a:pPr algn="r" indent="0" marL="0">
+              <a:lnSpc>
+                <a:spcPct val="110000"/>
+              </a:lnSpc>
+              <a:buNone/>
+            </a:pPr>
+            <a:r>
+              <a:rPr lang="en-US" sz="900" u="sng" dirty="0">
+                <a:solidFill>
+                  <a:srgbClr val="8C1C2B"/>
+                </a:solidFill>
+                <a:uFill>
+                  <a:solidFill>
+                    <a:srgbClr val="8C1C2B"/>
+                  </a:solidFill>
+                </a:uFill>
+                <a:latin typeface="Calibri" pitchFamily="34" charset="0"/>
+                <a:ea typeface="Calibri" pitchFamily="34" charset="-122"/>
+                <a:cs typeface="Calibri" pitchFamily="34" charset="-120"/>
+                <a:hlinkClick r:id="rId1" invalidUrl="" action="" tgtFrame="" tooltip="https://saksham869.github.io/munim/" history="1" highlightClick="0" endSnd="0">
+                  <a:extLst>
+                    <a:ext uri="{A12FA001-AC4F-418D-AE19-62706E023703}">
+                      <ahyp:hlinkClr xmlns:ahyp="http://schemas.microsoft.com/office/drawing/2018/hyperlinkcolor" val="tx"/>
+                    </a:ext>
+                  </a:extLst>
+                </a:hlinkClick>
+              </a:rPr>
+              <a:t>saksham869.github.io/munim</a:t>
+            </a:r>
+            <a:endParaRPr lang="en-US" sz="900" dirty="0"/>
+          </a:p>
+        </p:txBody>
+      </p:sp>
+      <p:sp>
+        <p:nvSpPr>
+          <p:cNvPr id="6" name="Text 4"/>
           <p:cNvSpPr txBox="1"/>
           <p:nvPr/>
         </p:nvSpPr>
@@ -2791,7 +2954,7 @@
       </p:sp>
       <p:sp>
         <p:nvSpPr>
-          <p:cNvPr id="6" name="Shape 4"/>
+          <p:cNvPr id="7" name="Shape 5"/>
           <p:cNvSpPr/>
           <p:nvPr/>
         </p:nvSpPr>
@@ -2818,7 +2981,7 @@
       </p:sp>
       <p:sp>
         <p:nvSpPr>
-          <p:cNvPr id="7" name="Text 5"/>
+          <p:cNvPr id="8" name="Text 6"/>
           <p:cNvSpPr txBox="1"/>
           <p:nvPr/>
         </p:nvSpPr>
@@ -2852,7 +3015,7 @@
                 <a:ea typeface="Cambria" pitchFamily="34" charset="-122"/>
                 <a:cs typeface="Cambria" pitchFamily="34" charset="-120"/>
               </a:rPr>
-              <a:t>Bundled</a:t>
+              <a:t>Bundled into Pi</a:t>
             </a:r>
             <a:endParaRPr lang="en-US" sz="1700" dirty="0"/>
           </a:p>
@@ -2860,7 +3023,7 @@
       </p:sp>
       <p:sp>
         <p:nvSpPr>
-          <p:cNvPr id="8" name="Text 6"/>
+          <p:cNvPr id="9" name="Text 7"/>
           <p:cNvSpPr txBox="1"/>
           <p:nvPr/>
         </p:nvSpPr>
@@ -2894,7 +3057,7 @@
                 <a:ea typeface="Calibri" pitchFamily="34" charset="-122"/>
                 <a:cs typeface="Calibri" pitchFamily="34" charset="-120"/>
               </a:rPr>
-              <a:t>Munim ships inside Pi Agents' plan for small businesses. It is what makes a growth agent safe to sell to a kirana.</a:t>
+              <a:t>Munim would ship inside Pi Agents for small businesses. Merchants pay for agent-run offers; the checks come with them.</a:t>
             </a:r>
             <a:endParaRPr lang="en-US" sz="1350" dirty="0"/>
           </a:p>
@@ -2902,7 +3065,7 @@
       </p:sp>
       <p:sp>
         <p:nvSpPr>
-          <p:cNvPr id="9" name="Shape 7"/>
+          <p:cNvPr id="10" name="Shape 8"/>
           <p:cNvSpPr/>
           <p:nvPr/>
         </p:nvSpPr>
@@ -2929,7 +3092,7 @@
       </p:sp>
       <p:sp>
         <p:nvSpPr>
-          <p:cNvPr id="10" name="Text 8"/>
+          <p:cNvPr id="11" name="Text 9"/>
           <p:cNvSpPr txBox="1"/>
           <p:nvPr/>
         </p:nvSpPr>
@@ -2963,7 +3126,7 @@
                 <a:ea typeface="Cambria" pitchFamily="34" charset="-122"/>
                 <a:cs typeface="Cambria" pitchFamily="34" charset="-120"/>
               </a:rPr>
-              <a:t>Outcome tier</a:t>
+              <a:t>What Paytm gets</a:t>
             </a:r>
             <a:endParaRPr lang="en-US" sz="1700" dirty="0"/>
           </a:p>
@@ -2971,7 +3134,7 @@
       </p:sp>
       <p:sp>
         <p:nvSpPr>
-          <p:cNvPr id="11" name="Text 9"/>
+          <p:cNvPr id="12" name="Text 10"/>
           <p:cNvSpPr txBox="1"/>
           <p:nvPr/>
         </p:nvSpPr>
@@ -3005,7 +3168,7 @@
                 <a:ea typeface="Calibri" pitchFamily="34" charset="-122"/>
                 <a:cs typeface="Calibri" pitchFamily="34" charset="-120"/>
               </a:rPr>
-              <a:t>Optional: Paytm keeps a share (say 10%) of measured net gain, only on offers Munim marks as worked.</a:t>
+              <a:t>Cashback offers it can sell to a kirana, with the owner's weekly budget as the worst case. The cashback moves on Paytm's rails.</a:t>
             </a:r>
             <a:endParaRPr lang="en-US" sz="1350" dirty="0"/>
           </a:p>
@@ -3013,7 +3176,7 @@
       </p:sp>
       <p:sp>
         <p:nvSpPr>
-          <p:cNvPr id="12" name="Shape 10"/>
+          <p:cNvPr id="13" name="Shape 11"/>
           <p:cNvSpPr/>
           <p:nvPr/>
         </p:nvSpPr>
@@ -3040,7 +3203,7 @@
       </p:sp>
       <p:sp>
         <p:nvSpPr>
-          <p:cNvPr id="13" name="Text 11"/>
+          <p:cNvPr id="14" name="Text 12"/>
           <p:cNvSpPr txBox="1"/>
           <p:nvPr/>
         </p:nvSpPr>
@@ -3074,7 +3237,7 @@
                 <a:ea typeface="Cambria" pitchFamily="34" charset="-122"/>
                 <a:cs typeface="Cambria" pitchFamily="34" charset="-120"/>
               </a:rPr>
-              <a:t>Near-zero running cost</a:t>
+              <a:t>Outcome fee, later</a:t>
             </a:r>
             <a:endParaRPr lang="en-US" sz="1700" dirty="0"/>
           </a:p>
@@ -3082,7 +3245,7 @@
       </p:sp>
       <p:sp>
         <p:nvSpPr>
-          <p:cNvPr id="14" name="Text 12"/>
+          <p:cNvPr id="15" name="Text 13"/>
           <p:cNvSpPr txBox="1"/>
           <p:nvPr/>
         </p:nvSpPr>
@@ -3116,7 +3279,7 @@
                 <a:ea typeface="Calibri" pitchFamily="34" charset="-122"/>
                 <a:cs typeface="Calibri" pitchFamily="34" charset="-120"/>
               </a:rPr>
-              <a:t>Decisions are arithmetic, not inference. The LLM only drafts offers and phrases results.</a:t>
+              <a:t>Optional: a small share of measured net gain. The keep-or-stop rules are fixed before an offer runs, and the owner can recheck every verdict in the ledger.</a:t>
             </a:r>
             <a:endParaRPr lang="en-US" sz="1350" dirty="0"/>
           </a:p>
@@ -3124,7 +3287,7 @@
       </p:sp>
       <p:sp>
         <p:nvSpPr>
-          <p:cNvPr id="15" name="Shape 13"/>
+          <p:cNvPr id="16" name="Shape 14"/>
           <p:cNvSpPr/>
           <p:nvPr/>
         </p:nvSpPr>
@@ -3151,7 +3314,7 @@
       </p:sp>
       <p:sp>
         <p:nvSpPr>
-          <p:cNvPr id="16" name="Text 14"/>
+          <p:cNvPr id="17" name="Text 15"/>
           <p:cNvSpPr txBox="1"/>
           <p:nvPr/>
         </p:nvSpPr>
@@ -3185,7 +3348,7 @@
                 <a:ea typeface="Cambria" pitchFamily="34" charset="-122"/>
                 <a:cs typeface="Cambria" pitchFamily="34" charset="-120"/>
               </a:rPr>
-              <a:t>Beyond kiranas</a:t>
+              <a:t>Pilot before pricing</a:t>
             </a:r>
             <a:endParaRPr lang="en-US" sz="1700" dirty="0"/>
           </a:p>
@@ -3193,7 +3356,7 @@
       </p:sp>
       <p:sp>
         <p:nvSpPr>
-          <p:cNvPr id="17" name="Text 15"/>
+          <p:cNvPr id="18" name="Text 16"/>
           <p:cNvSpPr txBox="1"/>
           <p:nvPr/>
         </p:nvSpPr>
@@ -3227,7 +3390,7 @@
                 <a:ea typeface="Calibri" pitchFamily="34" charset="-122"/>
                 <a:cs typeface="Calibri" pitchFamily="34" charset="-120"/>
               </a:rPr>
-              <a:t>The same authority layer fits Pi's banks and insurers: collection incentives, cross-sell budgets.</a:t>
+              <a:t>50 kiranas for 8 weeks with Paytm, measuring reachable customers per shop, how often owners tap Haan, and the risky spend Munim refused.</a:t>
             </a:r>
             <a:endParaRPr lang="en-US" sz="1350" dirty="0"/>
           </a:p>
@@ -3235,7 +3398,7 @@
       </p:sp>
       <p:sp>
         <p:nvSpPr>
-          <p:cNvPr id="18" name="Shape 16"/>
+          <p:cNvPr id="19" name="Shape 17"/>
           <p:cNvSpPr/>
           <p:nvPr/>
         </p:nvSpPr>
@@ -3262,7 +3425,7 @@
       </p:sp>
       <p:sp>
         <p:nvSpPr>
-          <p:cNvPr id="19" name="Text 17"/>
+          <p:cNvPr id="20" name="Text 18"/>
           <p:cNvSpPr txBox="1"/>
           <p:nvPr/>
         </p:nvSpPr>
@@ -3304,7 +3467,7 @@
       </p:sp>
       <p:sp>
         <p:nvSpPr>
-          <p:cNvPr id="20" name="Text 18"/>
+          <p:cNvPr id="21" name="Text 19"/>
           <p:cNvSpPr txBox="1"/>
           <p:nvPr/>
         </p:nvSpPr>
@@ -3346,14 +3509,14 @@
       </p:sp>
       <p:sp>
         <p:nvSpPr>
-          <p:cNvPr id="21" name="Text 19"/>
+          <p:cNvPr id="22" name="Text 20"/>
           <p:cNvSpPr txBox="1"/>
           <p:nvPr/>
         </p:nvSpPr>
         <p:spPr>
           <a:xfrm>
             <a:off x="8183880" y="3200400"/>
-            <a:ext cx="3200400" cy="594360"/>
+            <a:ext cx="3200400" cy="777240"/>
           </a:xfrm>
           <a:prstGeom prst="rect">
             <a:avLst/>
@@ -3380,7 +3543,7 @@
                 <a:ea typeface="Calibri" pitchFamily="34" charset="-122"/>
                 <a:cs typeface="Calibri" pitchFamily="34" charset="-120"/>
               </a:rPr>
-              <a:t>a year if 1% of 1.57 Cr Soundbox merchants paid ₹99 a month</a:t>
+              <a:t>a year if 1% of the 1.57 Cr merchants on Paytm devices paid ₹99 a month for agent-run offers</a:t>
             </a:r>
             <a:endParaRPr lang="en-US" sz="1350" dirty="0"/>
           </a:p>
@@ -3388,13 +3551,13 @@
       </p:sp>
       <p:sp>
         <p:nvSpPr>
-          <p:cNvPr id="22" name="Text 20"/>
-          <p:cNvSpPr txBox="1"/>
-          <p:nvPr/>
-        </p:nvSpPr>
-        <p:spPr>
-          <a:xfrm>
-            <a:off x="8183880" y="3977640"/>
+          <p:cNvPr id="23" name="Text 21"/>
+          <p:cNvSpPr txBox="1"/>
+          <p:nvPr/>
+        </p:nvSpPr>
+        <p:spPr>
+          <a:xfrm>
+            <a:off x="8183880" y="4041648"/>
             <a:ext cx="3200400" cy="274320"/>
           </a:xfrm>
           <a:prstGeom prst="rect">
@@ -3422,7 +3585,7 @@
                 <a:ea typeface="Calibri" pitchFamily="34" charset="-122"/>
                 <a:cs typeface="Calibri" pitchFamily="34" charset="-120"/>
               </a:rPr>
-              <a:t>1.57 lakh × ₹99 × 12 = ₹18.65 Cr</a:t>
+              <a:t>1.57 lakh × ₹99 × 12 ≈ ₹18.6 Cr</a:t>
             </a:r>
             <a:endParaRPr lang="en-US" sz="1200" dirty="0"/>
           </a:p>
@@ -3430,14 +3593,14 @@
       </p:sp>
       <p:sp>
         <p:nvSpPr>
-          <p:cNvPr id="23" name="Text 21"/>
-          <p:cNvSpPr txBox="1"/>
-          <p:nvPr/>
-        </p:nvSpPr>
-        <p:spPr>
-          <a:xfrm>
-            <a:off x="8183880" y="4389120"/>
-            <a:ext cx="3200400" cy="1188720"/>
+          <p:cNvPr id="24" name="Text 22"/>
+          <p:cNvSpPr txBox="1"/>
+          <p:nvPr/>
+        </p:nvSpPr>
+        <p:spPr>
+          <a:xfrm>
+            <a:off x="8183880" y="4407408"/>
+            <a:ext cx="3200400" cy="640080"/>
           </a:xfrm>
           <a:prstGeom prst="rect">
             <a:avLst/>
@@ -3464,9 +3627,51 @@
                 <a:ea typeface="Calibri" pitchFamily="34" charset="-122"/>
                 <a:cs typeface="Calibri" pitchFamily="34" charset="-120"/>
               </a:rPr>
-              <a:t>An illustration of scale, not a forecast. It matches Paytm's stated plan to charge subscription plus inference for merchant agents.</a:t>
+              <a:t>An illustration, not a forecast. The ₹99 price and the 1% uptake are assumptions for the pilot to test.</a:t>
             </a:r>
             <a:endParaRPr lang="en-US" sz="1100" dirty="0"/>
+          </a:p>
+        </p:txBody>
+      </p:sp>
+      <p:sp>
+        <p:nvSpPr>
+          <p:cNvPr id="25" name="Text 23"/>
+          <p:cNvSpPr txBox="1"/>
+          <p:nvPr/>
+        </p:nvSpPr>
+        <p:spPr>
+          <a:xfrm>
+            <a:off x="8183880" y="5138928"/>
+            <a:ext cx="3200400" cy="502920"/>
+          </a:xfrm>
+          <a:prstGeom prst="rect">
+            <a:avLst/>
+          </a:prstGeom>
+          <a:noFill/>
+          <a:ln/>
+        </p:spPr>
+        <p:txBody>
+          <a:bodyPr wrap="square" lIns="0" tIns="0" rIns="0" bIns="0" rtlCol="0" anchor="t"/>
+          <a:lstStyle/>
+          <a:p>
+            <a:pPr algn="l" indent="0" marL="0">
+              <a:lnSpc>
+                <a:spcPct val="115000"/>
+              </a:lnSpc>
+              <a:buNone/>
+            </a:pPr>
+            <a:r>
+              <a:rPr lang="en-US" sz="1150" dirty="0">
+                <a:solidFill>
+                  <a:srgbClr val="D7D7DC"/>
+                </a:solidFill>
+                <a:latin typeface="Calibri" pitchFamily="34" charset="0"/>
+                <a:ea typeface="Calibri" pitchFamily="34" charset="-122"/>
+                <a:cs typeface="Calibri" pitchFamily="34" charset="-120"/>
+              </a:rPr>
+              <a:t>Running cost: near zero. Decisions are arithmetic, with no model call.</a:t>
+            </a:r>
+            <a:endParaRPr lang="en-US" sz="1150" dirty="0"/>
           </a:p>
         </p:txBody>
       </p:sp>
@@ -3642,7 +3847,7 @@
                 <a:ea typeface="Calibri" pitchFamily="34" charset="-122"/>
                 <a:cs typeface="Calibri" pitchFamily="34" charset="-120"/>
               </a:rPr>
-              <a:t>✓  Policy engine, measurement, passports, ledger</a:t>
+              <a:t>✓  Policy engine, measurement, passports, sealed ledger</a:t>
             </a:r>
             <a:endParaRPr lang="en-US" sz="1500" dirty="0"/>
           </a:p>
@@ -3684,7 +3889,7 @@
                 <a:ea typeface="Calibri" pitchFamily="34" charset="-122"/>
                 <a:cs typeface="Calibri" pitchFamily="34" charset="-120"/>
               </a:rPr>
-              <a:t>✓  143 automated tests</a:t>
+              <a:t>✓  180 automated tests</a:t>
             </a:r>
             <a:endParaRPr lang="en-US" sz="1500" dirty="0"/>
           </a:p>
@@ -3726,7 +3931,7 @@
                 <a:ea typeface="Calibri" pitchFamily="34" charset="-122"/>
                 <a:cs typeface="Calibri" pitchFamily="34" charset="-120"/>
               </a:rPr>
-              <a:t>✓  1,000-campaign measurement evaluation</a:t>
+              <a:t>✓  1,000-campaign evaluation with robustness checks</a:t>
             </a:r>
             <a:endParaRPr lang="en-US" sz="1500" dirty="0"/>
           </a:p>
@@ -3768,7 +3973,7 @@
                 <a:ea typeface="Calibri" pitchFamily="34" charset="-122"/>
                 <a:cs typeface="Calibri" pitchFamily="34" charset="-120"/>
               </a:rPr>
-              <a:t>✓  API and a live browser demo</a:t>
+              <a:t>✓  Live demo, API, import of your own payments</a:t>
             </a:r>
             <a:endParaRPr lang="en-US" sz="1500" dirty="0"/>
           </a:p>
@@ -3852,7 +4057,7 @@
                 <a:ea typeface="Calibri" pitchFamily="34" charset="-122"/>
                 <a:cs typeface="Calibri" pitchFamily="34" charset="-120"/>
               </a:rPr>
-              <a:t>→  Hindi voice flow on the Soundbox</a:t>
+              <a:t>→  Live LLM agent proposing in the demo</a:t>
             </a:r>
             <a:endParaRPr lang="en-US" sz="1500" dirty="0"/>
           </a:p>
@@ -3894,7 +4099,7 @@
                 <a:ea typeface="Calibri" pitchFamily="34" charset="-122"/>
                 <a:cs typeface="Calibri" pitchFamily="34" charset="-120"/>
               </a:rPr>
-              <a:t>→  Pooled baselines from real network data</a:t>
+              <a:t>→  The shop's own history in the measurement</a:t>
             </a:r>
             <a:endParaRPr lang="en-US" sz="1500" dirty="0"/>
           </a:p>
@@ -3936,7 +4141,7 @@
                 <a:ea typeface="Calibri" pitchFamily="34" charset="-122"/>
                 <a:cs typeface="Calibri" pitchFamily="34" charset="-120"/>
               </a:rPr>
-              <a:t>→  Real offer-rails integration</a:t>
+              <a:t>→  Hindi voice for rules and "sab band karo"</a:t>
             </a:r>
             <a:endParaRPr lang="en-US" sz="1500" dirty="0"/>
           </a:p>
@@ -3987,6 +4192,48 @@
       <p:sp>
         <p:nvSpPr>
           <p:cNvPr id="13" name="Text 11"/>
+          <p:cNvSpPr txBox="1"/>
+          <p:nvPr/>
+        </p:nvSpPr>
+        <p:spPr>
+          <a:xfrm>
+            <a:off x="6309360" y="4645152"/>
+            <a:ext cx="5303520" cy="274320"/>
+          </a:xfrm>
+          <a:prstGeom prst="rect">
+            <a:avLst/>
+          </a:prstGeom>
+          <a:noFill/>
+          <a:ln/>
+        </p:spPr>
+        <p:txBody>
+          <a:bodyPr wrap="square" lIns="0" tIns="0" rIns="0" bIns="0" rtlCol="0" anchor="t"/>
+          <a:lstStyle/>
+          <a:p>
+            <a:pPr algn="l" indent="0" marL="0">
+              <a:lnSpc>
+                <a:spcPct val="110000"/>
+              </a:lnSpc>
+              <a:buNone/>
+            </a:pPr>
+            <a:r>
+              <a:rPr lang="en-US" sz="1200" i="1" dirty="0">
+                <a:solidFill>
+                  <a:srgbClr val="A9A9B2"/>
+                </a:solidFill>
+                <a:latin typeface="Calibri" pitchFamily="34" charset="0"/>
+                <a:ea typeface="Calibri" pitchFamily="34" charset="-122"/>
+                <a:cs typeface="Calibri" pitchFamily="34" charset="-120"/>
+              </a:rPr>
+              <a:t>With Paytm, after the event: real cohorts, offer rails, consent.</a:t>
+            </a:r>
+            <a:endParaRPr lang="en-US" sz="1200" dirty="0"/>
+          </a:p>
+        </p:txBody>
+      </p:sp>
+      <p:sp>
+        <p:nvSpPr>
+          <p:cNvPr id="14" name="Text 12"/>
           <p:cNvSpPr txBox="1"/>
           <p:nvPr/>
         </p:nvSpPr>
@@ -4028,7 +4275,7 @@
       </p:sp>
       <p:sp>
         <p:nvSpPr>
-          <p:cNvPr id="14" name="Text 12"/>
+          <p:cNvPr id="15" name="Text 13"/>
           <p:cNvSpPr txBox="1"/>
           <p:nvPr/>
         </p:nvSpPr>
@@ -4070,7 +4317,7 @@
       </p:sp>
       <p:sp>
         <p:nvSpPr>
-          <p:cNvPr id="15" name="Text 13"/>
+          <p:cNvPr id="16" name="Text 14"/>
           <p:cNvSpPr txBox="1"/>
           <p:nvPr/>
         </p:nvSpPr>
@@ -4096,7 +4343,7 @@
               <a:buNone/>
             </a:pPr>
             <a:r>
-              <a:rPr lang="en-US" sz="1300" dirty="0">
+              <a:rPr lang="en-US" sz="1400" b="1" dirty="0">
                 <a:solidFill>
                   <a:srgbClr val="A9A9B2"/>
                 </a:solidFill>
@@ -4104,15 +4351,170 @@
                 <a:ea typeface="Calibri" pitchFamily="34" charset="-122"/>
                 <a:cs typeface="Calibri" pitchFamily="34" charset="-120"/>
               </a:rPr>
-              <a:t>github.com/saksham869/munim  ·  saksham869.github.io/munim  ·  mishrasatyam3456@gmail.com</a:t>
-            </a:r>
-            <a:endParaRPr lang="en-US" sz="1300" dirty="0"/>
-          </a:p>
-        </p:txBody>
-      </p:sp>
-      <p:sp>
-        <p:nvSpPr>
-          <p:cNvPr id="16" name="Text 14"/>
+              <a:t>Live demo  </a:t>
+            </a:r>
+            <a:pPr algn="l" indent="0" marL="0">
+              <a:lnSpc>
+                <a:spcPct val="110000"/>
+              </a:lnSpc>
+              <a:buNone/>
+            </a:pPr>
+            <a:r>
+              <a:rPr lang="en-US" sz="1400" b="1" u="sng" dirty="0">
+                <a:solidFill>
+                  <a:srgbClr val="E3A72F"/>
+                </a:solidFill>
+                <a:uFill>
+                  <a:solidFill>
+                    <a:srgbClr val="E3A72F"/>
+                  </a:solidFill>
+                </a:uFill>
+                <a:latin typeface="Calibri" pitchFamily="34" charset="0"/>
+                <a:ea typeface="Calibri" pitchFamily="34" charset="-122"/>
+                <a:cs typeface="Calibri" pitchFamily="34" charset="-120"/>
+                <a:hlinkClick r:id="rId1" invalidUrl="" action="" tgtFrame="" tooltip="https://saksham869.github.io/munim/" history="1" highlightClick="0" endSnd="0">
+                  <a:extLst>
+                    <a:ext uri="{A12FA001-AC4F-418D-AE19-62706E023703}">
+                      <ahyp:hlinkClr xmlns:ahyp="http://schemas.microsoft.com/office/drawing/2018/hyperlinkcolor" val="tx"/>
+                    </a:ext>
+                  </a:extLst>
+                </a:hlinkClick>
+              </a:rPr>
+              <a:t>saksham869.github.io/munim</a:t>
+            </a:r>
+            <a:pPr algn="l" indent="0" marL="0">
+              <a:lnSpc>
+                <a:spcPct val="110000"/>
+              </a:lnSpc>
+              <a:buNone/>
+            </a:pPr>
+            <a:r>
+              <a:rPr lang="en-US" sz="1400" dirty="0">
+                <a:solidFill>
+                  <a:srgbClr val="000000"/>
+                </a:solidFill>
+                <a:latin typeface="Calibri" pitchFamily="34" charset="0"/>
+                <a:ea typeface="Calibri" pitchFamily="34" charset="-122"/>
+                <a:cs typeface="Calibri" pitchFamily="34" charset="-120"/>
+              </a:rPr>
+              <a:t>        </a:t>
+            </a:r>
+            <a:pPr algn="l" indent="0" marL="0">
+              <a:lnSpc>
+                <a:spcPct val="110000"/>
+              </a:lnSpc>
+              <a:buNone/>
+            </a:pPr>
+            <a:r>
+              <a:rPr lang="en-US" sz="1400" b="1" dirty="0">
+                <a:solidFill>
+                  <a:srgbClr val="A9A9B2"/>
+                </a:solidFill>
+                <a:latin typeface="Calibri" pitchFamily="34" charset="0"/>
+                <a:ea typeface="Calibri" pitchFamily="34" charset="-122"/>
+                <a:cs typeface="Calibri" pitchFamily="34" charset="-120"/>
+              </a:rPr>
+              <a:t>Code  </a:t>
+            </a:r>
+            <a:pPr algn="l" indent="0" marL="0">
+              <a:lnSpc>
+                <a:spcPct val="110000"/>
+              </a:lnSpc>
+              <a:buNone/>
+            </a:pPr>
+            <a:r>
+              <a:rPr lang="en-US" sz="1400" b="1" u="sng" dirty="0">
+                <a:solidFill>
+                  <a:srgbClr val="E3A72F"/>
+                </a:solidFill>
+                <a:uFill>
+                  <a:solidFill>
+                    <a:srgbClr val="E3A72F"/>
+                  </a:solidFill>
+                </a:uFill>
+                <a:latin typeface="Calibri" pitchFamily="34" charset="0"/>
+                <a:ea typeface="Calibri" pitchFamily="34" charset="-122"/>
+                <a:cs typeface="Calibri" pitchFamily="34" charset="-120"/>
+                <a:hlinkClick r:id="rId2" invalidUrl="" action="" tgtFrame="" tooltip="https://github.com/saksham869/munim" history="1" highlightClick="0" endSnd="0">
+                  <a:extLst>
+                    <a:ext uri="{A12FA001-AC4F-418D-AE19-62706E023703}">
+                      <ahyp:hlinkClr xmlns:ahyp="http://schemas.microsoft.com/office/drawing/2018/hyperlinkcolor" val="tx"/>
+                    </a:ext>
+                  </a:extLst>
+                </a:hlinkClick>
+              </a:rPr>
+              <a:t>github.com/saksham869/munim</a:t>
+            </a:r>
+            <a:pPr algn="l" indent="0" marL="0">
+              <a:lnSpc>
+                <a:spcPct val="110000"/>
+              </a:lnSpc>
+              <a:buNone/>
+            </a:pPr>
+            <a:r>
+              <a:rPr lang="en-US" sz="1400" dirty="0">
+                <a:solidFill>
+                  <a:srgbClr val="000000"/>
+                </a:solidFill>
+                <a:latin typeface="Calibri" pitchFamily="34" charset="0"/>
+                <a:ea typeface="Calibri" pitchFamily="34" charset="-122"/>
+                <a:cs typeface="Calibri" pitchFamily="34" charset="-120"/>
+              </a:rPr>
+              <a:t>        </a:t>
+            </a:r>
+            <a:pPr algn="l" indent="0" marL="0">
+              <a:lnSpc>
+                <a:spcPct val="110000"/>
+              </a:lnSpc>
+              <a:buNone/>
+            </a:pPr>
+            <a:r>
+              <a:rPr lang="en-US" sz="1400" b="1" dirty="0">
+                <a:solidFill>
+                  <a:srgbClr val="A9A9B2"/>
+                </a:solidFill>
+                <a:latin typeface="Calibri" pitchFamily="34" charset="0"/>
+                <a:ea typeface="Calibri" pitchFamily="34" charset="-122"/>
+                <a:cs typeface="Calibri" pitchFamily="34" charset="-120"/>
+              </a:rPr>
+              <a:t>Email  </a:t>
+            </a:r>
+            <a:pPr algn="l" indent="0" marL="0">
+              <a:lnSpc>
+                <a:spcPct val="110000"/>
+              </a:lnSpc>
+              <a:buNone/>
+            </a:pPr>
+            <a:r>
+              <a:rPr lang="en-US" sz="1400" b="1" u="sng" dirty="0">
+                <a:solidFill>
+                  <a:srgbClr val="E3A72F"/>
+                </a:solidFill>
+                <a:uFill>
+                  <a:solidFill>
+                    <a:srgbClr val="E3A72F"/>
+                  </a:solidFill>
+                </a:uFill>
+                <a:latin typeface="Calibri" pitchFamily="34" charset="0"/>
+                <a:ea typeface="Calibri" pitchFamily="34" charset="-122"/>
+                <a:cs typeface="Calibri" pitchFamily="34" charset="-120"/>
+                <a:hlinkClick r:id="rId3" invalidUrl="" action="" tgtFrame="" tooltip="mailto:mishrasatyam3456@gmail.com" history="1" highlightClick="0" endSnd="0">
+                  <a:extLst>
+                    <a:ext uri="{A12FA001-AC4F-418D-AE19-62706E023703}">
+                      <ahyp:hlinkClr xmlns:ahyp="http://schemas.microsoft.com/office/drawing/2018/hyperlinkcolor" val="tx"/>
+                    </a:ext>
+                  </a:extLst>
+                </a:hlinkClick>
+              </a:rPr>
+              <a:t>mishrasatyam3456@gmail.com</a:t>
+            </a:r>
+            <a:endParaRPr lang="en-US" sz="1400" dirty="0"/>
+          </a:p>
+        </p:txBody>
+      </p:sp>
+      <p:sp>
+        <p:nvSpPr>
+          <p:cNvPr id="17" name="Text 15"/>
           <p:cNvSpPr txBox="1"/>
           <p:nvPr/>
         </p:nvSpPr>
@@ -4277,7 +4679,7 @@
         <p:spPr>
           <a:xfrm>
             <a:off x="548640" y="6419088"/>
-            <a:ext cx="7315200" cy="228600"/>
+            <a:ext cx="5852160" cy="228600"/>
           </a:xfrm>
           <a:prstGeom prst="rect">
             <a:avLst/>
@@ -4313,6 +4715,77 @@
       <p:sp>
         <p:nvSpPr>
           <p:cNvPr id="5" name="Text 3"/>
+          <p:cNvSpPr txBox="1"/>
+          <p:nvPr/>
+        </p:nvSpPr>
+        <p:spPr>
+          <a:xfrm>
+            <a:off x="6583680" y="6419088"/>
+            <a:ext cx="4510735" cy="228600"/>
+          </a:xfrm>
+          <a:prstGeom prst="rect">
+            <a:avLst/>
+          </a:prstGeom>
+          <a:noFill/>
+          <a:ln/>
+        </p:spPr>
+        <p:txBody>
+          <a:bodyPr wrap="square" lIns="0" tIns="0" rIns="0" bIns="0" rtlCol="0" anchor="t"/>
+          <a:lstStyle/>
+          <a:p>
+            <a:pPr algn="r" indent="0" marL="0">
+              <a:lnSpc>
+                <a:spcPct val="110000"/>
+              </a:lnSpc>
+              <a:buNone/>
+            </a:pPr>
+            <a:r>
+              <a:rPr lang="en-US" sz="900" b="1" dirty="0">
+                <a:solidFill>
+                  <a:srgbClr val="6B6B73"/>
+                </a:solidFill>
+                <a:latin typeface="Calibri" pitchFamily="34" charset="0"/>
+                <a:ea typeface="Calibri" pitchFamily="34" charset="-122"/>
+                <a:cs typeface="Calibri" pitchFamily="34" charset="-120"/>
+              </a:rPr>
+              <a:t>Live demo  </a:t>
+            </a:r>
+            <a:pPr algn="r" indent="0" marL="0">
+              <a:lnSpc>
+                <a:spcPct val="110000"/>
+              </a:lnSpc>
+              <a:buNone/>
+            </a:pPr>
+            <a:r>
+              <a:rPr lang="en-US" sz="900" u="sng" dirty="0">
+                <a:solidFill>
+                  <a:srgbClr val="8C1C2B"/>
+                </a:solidFill>
+                <a:uFill>
+                  <a:solidFill>
+                    <a:srgbClr val="8C1C2B"/>
+                  </a:solidFill>
+                </a:uFill>
+                <a:latin typeface="Calibri" pitchFamily="34" charset="0"/>
+                <a:ea typeface="Calibri" pitchFamily="34" charset="-122"/>
+                <a:cs typeface="Calibri" pitchFamily="34" charset="-120"/>
+                <a:hlinkClick r:id="rId1" invalidUrl="" action="" tgtFrame="" tooltip="https://saksham869.github.io/munim/" history="1" highlightClick="0" endSnd="0">
+                  <a:extLst>
+                    <a:ext uri="{A12FA001-AC4F-418D-AE19-62706E023703}">
+                      <ahyp:hlinkClr xmlns:ahyp="http://schemas.microsoft.com/office/drawing/2018/hyperlinkcolor" val="tx"/>
+                    </a:ext>
+                  </a:extLst>
+                </a:hlinkClick>
+              </a:rPr>
+              <a:t>saksham869.github.io/munim</a:t>
+            </a:r>
+            <a:endParaRPr lang="en-US" sz="900" dirty="0"/>
+          </a:p>
+        </p:txBody>
+      </p:sp>
+      <p:sp>
+        <p:nvSpPr>
+          <p:cNvPr id="6" name="Text 4"/>
           <p:cNvSpPr txBox="1"/>
           <p:nvPr/>
         </p:nvSpPr>
@@ -4354,7 +4827,7 @@
       </p:sp>
       <p:sp>
         <p:nvSpPr>
-          <p:cNvPr id="6" name="Text 4"/>
+          <p:cNvPr id="7" name="Text 5"/>
           <p:cNvSpPr txBox="1"/>
           <p:nvPr/>
         </p:nvSpPr>
@@ -4396,7 +4869,7 @@
       </p:sp>
       <p:sp>
         <p:nvSpPr>
-          <p:cNvPr id="7" name="Text 5"/>
+          <p:cNvPr id="8" name="Text 6"/>
           <p:cNvSpPr txBox="1"/>
           <p:nvPr/>
         </p:nvSpPr>
@@ -4430,7 +4903,7 @@
                 <a:ea typeface="Calibri" pitchFamily="34" charset="-122"/>
                 <a:cs typeface="Calibri" pitchFamily="34" charset="-120"/>
               </a:rPr>
-              <a:t>merchants on Paytm Soundbox and devices (Q1 FY27)</a:t>
+              <a:t>merchants paying for Paytm payment devices (Q1 FY27)</a:t>
             </a:r>
             <a:endParaRPr lang="en-US" sz="1300" dirty="0"/>
           </a:p>
@@ -4438,33 +4911,33 @@
       </p:sp>
       <p:sp>
         <p:nvSpPr>
-          <p:cNvPr id="8" name="Text 6"/>
-          <p:cNvSpPr txBox="1"/>
-          <p:nvPr/>
-        </p:nvSpPr>
-        <p:spPr>
-          <a:xfrm>
-            <a:off x="548640" y="3108960"/>
-            <a:ext cx="4023360" cy="1188720"/>
-          </a:xfrm>
-          <a:prstGeom prst="rect">
-            <a:avLst/>
-          </a:prstGeom>
-          <a:noFill/>
-          <a:ln/>
-        </p:spPr>
-        <p:txBody>
-          <a:bodyPr wrap="square" lIns="0" tIns="0" rIns="0" bIns="0" rtlCol="0" anchor="t"/>
-          <a:lstStyle/>
-          <a:p>
-            <a:pPr algn="l" indent="0" marL="0">
-              <a:lnSpc>
-                <a:spcPct val="120000"/>
-              </a:lnSpc>
-              <a:buNone/>
-            </a:pPr>
-            <a:r>
-              <a:rPr lang="en-US" sz="1500" dirty="0">
+          <p:cNvPr id="9" name="Text 7"/>
+          <p:cNvSpPr txBox="1"/>
+          <p:nvPr/>
+        </p:nvSpPr>
+        <p:spPr>
+          <a:xfrm>
+            <a:off x="548640" y="3063240"/>
+            <a:ext cx="4023360" cy="1280160"/>
+          </a:xfrm>
+          <a:prstGeom prst="rect">
+            <a:avLst/>
+          </a:prstGeom>
+          <a:noFill/>
+          <a:ln/>
+        </p:spPr>
+        <p:txBody>
+          <a:bodyPr wrap="square" lIns="0" tIns="0" rIns="0" bIns="0" rtlCol="0" anchor="t"/>
+          <a:lstStyle/>
+          <a:p>
+            <a:pPr algn="l" indent="0" marL="0">
+              <a:lnSpc>
+                <a:spcPct val="118000"/>
+              </a:lnSpc>
+              <a:buNone/>
+            </a:pPr>
+            <a:r>
+              <a:rPr lang="en-US" sz="1400" dirty="0">
                 <a:solidFill>
                   <a:srgbClr val="1B1B1F"/>
                 </a:solidFill>
@@ -4472,15 +4945,15 @@
                 <a:ea typeface="Calibri" pitchFamily="34" charset="-122"/>
                 <a:cs typeface="Calibri" pitchFamily="34" charset="-120"/>
               </a:rPr>
-              <a:t>Paytm is building agents for merchant marketing and customer engagement, and Pi Agents already run campaigns, loyalty and cashback for small businesses.</a:t>
-            </a:r>
-            <a:endParaRPr lang="en-US" sz="1500" dirty="0"/>
-          </a:p>
-        </p:txBody>
-      </p:sp>
-      <p:sp>
-        <p:nvSpPr>
-          <p:cNvPr id="9" name="Text 7"/>
+              <a:t>Paytm's Pi Sales &amp; Marketing Agent already spends on ads for small businesses: Pi suggests the budget, the owner taps approve. Cashback to a shop's own customers is the next lever, and the riskier one.</a:t>
+            </a:r>
+            <a:endParaRPr lang="en-US" sz="1400" dirty="0"/>
+          </a:p>
+        </p:txBody>
+      </p:sp>
+      <p:sp>
+        <p:nvSpPr>
+          <p:cNvPr id="10" name="Text 8"/>
           <p:cNvSpPr txBox="1"/>
           <p:nvPr/>
         </p:nvSpPr>
@@ -4522,7 +4995,7 @@
       </p:sp>
       <p:sp>
         <p:nvSpPr>
-          <p:cNvPr id="10" name="Shape 8"/>
+          <p:cNvPr id="11" name="Shape 9"/>
           <p:cNvSpPr/>
           <p:nvPr/>
         </p:nvSpPr>
@@ -4549,7 +5022,7 @@
       </p:sp>
       <p:sp>
         <p:nvSpPr>
-          <p:cNvPr id="11" name="Shape 9"/>
+          <p:cNvPr id="12" name="Shape 10"/>
           <p:cNvSpPr/>
           <p:nvPr/>
         </p:nvSpPr>
@@ -4576,7 +5049,7 @@
       </p:sp>
       <p:sp>
         <p:nvSpPr>
-          <p:cNvPr id="12" name="Text 10"/>
+          <p:cNvPr id="13" name="Text 11"/>
           <p:cNvSpPr txBox="1"/>
           <p:nvPr/>
         </p:nvSpPr>
@@ -4618,7 +5091,7 @@
       </p:sp>
       <p:sp>
         <p:nvSpPr>
-          <p:cNvPr id="13" name="Text 11"/>
+          <p:cNvPr id="14" name="Text 12"/>
           <p:cNvSpPr txBox="1"/>
           <p:nvPr/>
         </p:nvSpPr>
@@ -4660,7 +5133,7 @@
       </p:sp>
       <p:sp>
         <p:nvSpPr>
-          <p:cNvPr id="14" name="Text 12"/>
+          <p:cNvPr id="15" name="Text 13"/>
           <p:cNvSpPr txBox="1"/>
           <p:nvPr/>
         </p:nvSpPr>
@@ -4694,7 +5167,7 @@
                 <a:ea typeface="Calibri" pitchFamily="34" charset="-122"/>
                 <a:cs typeface="Calibri" pitchFamily="34" charset="-120"/>
               </a:rPr>
-              <a:t>₹40 back on a typical ₹341 bill at 12% margin loses money even if every customer comes back.</a:t>
+              <a:t>₹40 back on a ₹100 bill: the shop earns ₹12 and pays out ₹40.</a:t>
             </a:r>
             <a:endParaRPr lang="en-US" sz="1300" dirty="0"/>
           </a:p>
@@ -4702,7 +5175,7 @@
       </p:sp>
       <p:sp>
         <p:nvSpPr>
-          <p:cNvPr id="15" name="Shape 13"/>
+          <p:cNvPr id="16" name="Shape 14"/>
           <p:cNvSpPr/>
           <p:nvPr/>
         </p:nvSpPr>
@@ -4729,7 +5202,7 @@
       </p:sp>
       <p:sp>
         <p:nvSpPr>
-          <p:cNvPr id="16" name="Shape 14"/>
+          <p:cNvPr id="17" name="Shape 15"/>
           <p:cNvSpPr/>
           <p:nvPr/>
         </p:nvSpPr>
@@ -4756,7 +5229,7 @@
       </p:sp>
       <p:sp>
         <p:nvSpPr>
-          <p:cNvPr id="17" name="Text 15"/>
+          <p:cNvPr id="18" name="Text 16"/>
           <p:cNvSpPr txBox="1"/>
           <p:nvPr/>
         </p:nvSpPr>
@@ -4798,7 +5271,7 @@
       </p:sp>
       <p:sp>
         <p:nvSpPr>
-          <p:cNvPr id="18" name="Text 16"/>
+          <p:cNvPr id="19" name="Text 17"/>
           <p:cNvSpPr txBox="1"/>
           <p:nvPr/>
         </p:nvSpPr>
@@ -4840,7 +5313,7 @@
       </p:sp>
       <p:sp>
         <p:nvSpPr>
-          <p:cNvPr id="19" name="Text 17"/>
+          <p:cNvPr id="20" name="Text 18"/>
           <p:cNvSpPr txBox="1"/>
           <p:nvPr/>
         </p:nvSpPr>
@@ -4882,7 +5355,7 @@
       </p:sp>
       <p:sp>
         <p:nvSpPr>
-          <p:cNvPr id="20" name="Shape 18"/>
+          <p:cNvPr id="21" name="Shape 19"/>
           <p:cNvSpPr/>
           <p:nvPr/>
         </p:nvSpPr>
@@ -4909,7 +5382,7 @@
       </p:sp>
       <p:sp>
         <p:nvSpPr>
-          <p:cNvPr id="21" name="Shape 19"/>
+          <p:cNvPr id="22" name="Shape 20"/>
           <p:cNvSpPr/>
           <p:nvPr/>
         </p:nvSpPr>
@@ -4936,7 +5409,7 @@
       </p:sp>
       <p:sp>
         <p:nvSpPr>
-          <p:cNvPr id="22" name="Text 20"/>
+          <p:cNvPr id="23" name="Text 21"/>
           <p:cNvSpPr txBox="1"/>
           <p:nvPr/>
         </p:nvSpPr>
@@ -4978,7 +5451,7 @@
       </p:sp>
       <p:sp>
         <p:nvSpPr>
-          <p:cNvPr id="23" name="Text 21"/>
+          <p:cNvPr id="24" name="Text 22"/>
           <p:cNvSpPr txBox="1"/>
           <p:nvPr/>
         </p:nvSpPr>
@@ -5020,7 +5493,7 @@
       </p:sp>
       <p:sp>
         <p:nvSpPr>
-          <p:cNvPr id="24" name="Text 22"/>
+          <p:cNvPr id="25" name="Text 23"/>
           <p:cNvSpPr txBox="1"/>
           <p:nvPr/>
         </p:nvSpPr>
@@ -5054,7 +5527,7 @@
                 <a:ea typeface="Calibri" pitchFamily="34" charset="-122"/>
                 <a:cs typeface="Calibri" pitchFamily="34" charset="-120"/>
               </a:rPr>
-              <a:t>With a 6–9 person comparison group, the shop's own numbers would have killed the offer that worked and kept the one that did not.</a:t>
+              <a:t>With comparison groups this small (6 to 9 people in the demo), a shop judging by them alone stops 45% of offers that were making money (1,000 simulated campaigns).</a:t>
             </a:r>
             <a:endParaRPr lang="en-US" sz="1300" dirty="0"/>
           </a:p>
@@ -5062,14 +5535,14 @@
       </p:sp>
       <p:sp>
         <p:nvSpPr>
-          <p:cNvPr id="25" name="Text 23"/>
+          <p:cNvPr id="26" name="Text 24"/>
           <p:cNvSpPr txBox="1"/>
           <p:nvPr/>
         </p:nvSpPr>
         <p:spPr>
           <a:xfrm>
             <a:off x="548640" y="5257800"/>
-            <a:ext cx="4023360" cy="822960"/>
+            <a:ext cx="4023360" cy="868680"/>
           </a:xfrm>
           <a:prstGeom prst="rect">
             <a:avLst/>
@@ -5096,7 +5569,7 @@
                 <a:ea typeface="Calibri" pitchFamily="34" charset="-122"/>
                 <a:cs typeface="Calibri" pitchFamily="34" charset="-120"/>
               </a:rPr>
-              <a:t>Card numbers come from Munim's run on a synthetic kirana (see the live demo). Kirana margins are already thin: a distributors' federation estimates about 2 lakh kiranas shut in a year amid quick commerce (AICPDF, 2024).</a:t>
+              <a:t>Card numbers: Munim's run on a synthetic kirana (live demo). Margins are already thin: a distributors' federation estimates about 2 lakh kiranas shut in a year amid quick commerce (AICPDF, 2024). Sources: Paytm Q1 FY27 results, Jul 2026; Paytm blog on Pi, Sep 2026; AI Soundbox: FoneArena, Oct 2025.</a:t>
             </a:r>
             <a:endParaRPr lang="en-US" sz="1050" dirty="0"/>
           </a:p>
@@ -5227,7 +5700,7 @@
         <p:spPr>
           <a:xfrm>
             <a:off x="548640" y="6419088"/>
-            <a:ext cx="7315200" cy="228600"/>
+            <a:ext cx="5852160" cy="228600"/>
           </a:xfrm>
           <a:prstGeom prst="rect">
             <a:avLst/>
@@ -5263,6 +5736,77 @@
       <p:sp>
         <p:nvSpPr>
           <p:cNvPr id="5" name="Text 3"/>
+          <p:cNvSpPr txBox="1"/>
+          <p:nvPr/>
+        </p:nvSpPr>
+        <p:spPr>
+          <a:xfrm>
+            <a:off x="6583680" y="6419088"/>
+            <a:ext cx="4510735" cy="228600"/>
+          </a:xfrm>
+          <a:prstGeom prst="rect">
+            <a:avLst/>
+          </a:prstGeom>
+          <a:noFill/>
+          <a:ln/>
+        </p:spPr>
+        <p:txBody>
+          <a:bodyPr wrap="square" lIns="0" tIns="0" rIns="0" bIns="0" rtlCol="0" anchor="t"/>
+          <a:lstStyle/>
+          <a:p>
+            <a:pPr algn="r" indent="0" marL="0">
+              <a:lnSpc>
+                <a:spcPct val="110000"/>
+              </a:lnSpc>
+              <a:buNone/>
+            </a:pPr>
+            <a:r>
+              <a:rPr lang="en-US" sz="900" b="1" dirty="0">
+                <a:solidFill>
+                  <a:srgbClr val="6B6B73"/>
+                </a:solidFill>
+                <a:latin typeface="Calibri" pitchFamily="34" charset="0"/>
+                <a:ea typeface="Calibri" pitchFamily="34" charset="-122"/>
+                <a:cs typeface="Calibri" pitchFamily="34" charset="-120"/>
+              </a:rPr>
+              <a:t>Live demo  </a:t>
+            </a:r>
+            <a:pPr algn="r" indent="0" marL="0">
+              <a:lnSpc>
+                <a:spcPct val="110000"/>
+              </a:lnSpc>
+              <a:buNone/>
+            </a:pPr>
+            <a:r>
+              <a:rPr lang="en-US" sz="900" u="sng" dirty="0">
+                <a:solidFill>
+                  <a:srgbClr val="8C1C2B"/>
+                </a:solidFill>
+                <a:uFill>
+                  <a:solidFill>
+                    <a:srgbClr val="8C1C2B"/>
+                  </a:solidFill>
+                </a:uFill>
+                <a:latin typeface="Calibri" pitchFamily="34" charset="0"/>
+                <a:ea typeface="Calibri" pitchFamily="34" charset="-122"/>
+                <a:cs typeface="Calibri" pitchFamily="34" charset="-120"/>
+                <a:hlinkClick r:id="rId1" invalidUrl="" action="" tgtFrame="" tooltip="https://saksham869.github.io/munim/" history="1" highlightClick="0" endSnd="0">
+                  <a:extLst>
+                    <a:ext uri="{A12FA001-AC4F-418D-AE19-62706E023703}">
+                      <ahyp:hlinkClr xmlns:ahyp="http://schemas.microsoft.com/office/drawing/2018/hyperlinkcolor" val="tx"/>
+                    </a:ext>
+                  </a:extLst>
+                </a:hlinkClick>
+              </a:rPr>
+              <a:t>saksham869.github.io/munim</a:t>
+            </a:r>
+            <a:endParaRPr lang="en-US" sz="900" dirty="0"/>
+          </a:p>
+        </p:txBody>
+      </p:sp>
+      <p:sp>
+        <p:nvSpPr>
+          <p:cNvPr id="6" name="Text 4"/>
           <p:cNvSpPr txBox="1"/>
           <p:nvPr/>
         </p:nvSpPr>
@@ -5304,7 +5848,7 @@
       </p:sp>
       <p:sp>
         <p:nvSpPr>
-          <p:cNvPr id="6" name="Shape 4"/>
+          <p:cNvPr id="7" name="Shape 5"/>
           <p:cNvSpPr/>
           <p:nvPr/>
         </p:nvSpPr>
@@ -5331,7 +5875,7 @@
       </p:sp>
       <p:sp>
         <p:nvSpPr>
-          <p:cNvPr id="7" name="Shape 5"/>
+          <p:cNvPr id="8" name="Shape 6"/>
           <p:cNvSpPr/>
           <p:nvPr/>
         </p:nvSpPr>
@@ -5356,7 +5900,7 @@
       </p:sp>
       <p:sp>
         <p:nvSpPr>
-          <p:cNvPr id="8" name="Text 6"/>
+          <p:cNvPr id="9" name="Text 7"/>
           <p:cNvSpPr txBox="1"/>
           <p:nvPr/>
         </p:nvSpPr>
@@ -5398,7 +5942,7 @@
       </p:sp>
       <p:sp>
         <p:nvSpPr>
-          <p:cNvPr id="9" name="Text 7"/>
+          <p:cNvPr id="10" name="Text 8"/>
           <p:cNvSpPr txBox="1"/>
           <p:nvPr/>
         </p:nvSpPr>
@@ -5440,7 +5984,7 @@
       </p:sp>
       <p:sp>
         <p:nvSpPr>
-          <p:cNvPr id="10" name="Text 8"/>
+          <p:cNvPr id="11" name="Text 9"/>
           <p:cNvSpPr txBox="1"/>
           <p:nvPr/>
         </p:nvSpPr>
@@ -5474,7 +6018,7 @@
                 <a:ea typeface="Calibri" pitchFamily="34" charset="-122"/>
                 <a:cs typeface="Calibri" pitchFamily="34" charset="-120"/>
               </a:rPr>
-              <a:t>Once, by voice on the Soundbox: ₹500 a week, keep 6% on every bill, ask me above ₹300.</a:t>
+              <a:t>Once, by voice on the Paytm AI Soundbox or in the app: ₹500 a week, keep 6% a bill, ask me above ₹300.</a:t>
             </a:r>
             <a:endParaRPr lang="en-US" sz="1300" dirty="0"/>
           </a:p>
@@ -5482,7 +6026,7 @@
       </p:sp>
       <p:sp>
         <p:nvSpPr>
-          <p:cNvPr id="11" name="Shape 9"/>
+          <p:cNvPr id="12" name="Shape 10"/>
           <p:cNvSpPr/>
           <p:nvPr/>
         </p:nvSpPr>
@@ -5506,7 +6050,7 @@
       </p:sp>
       <p:sp>
         <p:nvSpPr>
-          <p:cNvPr id="12" name="Shape 10"/>
+          <p:cNvPr id="13" name="Shape 11"/>
           <p:cNvSpPr/>
           <p:nvPr/>
         </p:nvSpPr>
@@ -5533,7 +6077,7 @@
       </p:sp>
       <p:sp>
         <p:nvSpPr>
-          <p:cNvPr id="13" name="Shape 11"/>
+          <p:cNvPr id="14" name="Shape 12"/>
           <p:cNvSpPr/>
           <p:nvPr/>
         </p:nvSpPr>
@@ -5558,7 +6102,7 @@
       </p:sp>
       <p:sp>
         <p:nvSpPr>
-          <p:cNvPr id="14" name="Text 12"/>
+          <p:cNvPr id="15" name="Text 13"/>
           <p:cNvSpPr txBox="1"/>
           <p:nvPr/>
         </p:nvSpPr>
@@ -5600,7 +6144,7 @@
       </p:sp>
       <p:sp>
         <p:nvSpPr>
-          <p:cNvPr id="15" name="Text 13"/>
+          <p:cNvPr id="16" name="Text 14"/>
           <p:cNvSpPr txBox="1"/>
           <p:nvPr/>
         </p:nvSpPr>
@@ -5642,7 +6186,7 @@
       </p:sp>
       <p:sp>
         <p:nvSpPr>
-          <p:cNvPr id="16" name="Text 14"/>
+          <p:cNvPr id="17" name="Text 15"/>
           <p:cNvSpPr txBox="1"/>
           <p:nvPr/>
         </p:nvSpPr>
@@ -5676,7 +6220,7 @@
                 <a:ea typeface="Calibri" pitchFamily="34" charset="-122"/>
                 <a:cs typeface="Calibri" pitchFamily="34" charset="-120"/>
               </a:rPr>
-              <a:t>Pi Agents or any LLM suggests an offer: which customers, how much cashback, what minimum bill.</a:t>
+              <a:t>Any LLM today, Pi agents later, suggests an offer: who gets it, how much cashback, what minimum bill.</a:t>
             </a:r>
             <a:endParaRPr lang="en-US" sz="1300" dirty="0"/>
           </a:p>
@@ -5684,7 +6228,7 @@
       </p:sp>
       <p:sp>
         <p:nvSpPr>
-          <p:cNvPr id="17" name="Shape 15"/>
+          <p:cNvPr id="18" name="Shape 16"/>
           <p:cNvSpPr/>
           <p:nvPr/>
         </p:nvSpPr>
@@ -5708,7 +6252,7 @@
       </p:sp>
       <p:sp>
         <p:nvSpPr>
-          <p:cNvPr id="18" name="Shape 16"/>
+          <p:cNvPr id="19" name="Shape 17"/>
           <p:cNvSpPr/>
           <p:nvPr/>
         </p:nvSpPr>
@@ -5735,7 +6279,7 @@
       </p:sp>
       <p:sp>
         <p:nvSpPr>
-          <p:cNvPr id="19" name="Shape 17"/>
+          <p:cNvPr id="20" name="Shape 18"/>
           <p:cNvSpPr/>
           <p:nvPr/>
         </p:nvSpPr>
@@ -5760,7 +6304,7 @@
       </p:sp>
       <p:sp>
         <p:nvSpPr>
-          <p:cNvPr id="20" name="Text 18"/>
+          <p:cNvPr id="21" name="Text 19"/>
           <p:cNvSpPr txBox="1"/>
           <p:nvPr/>
         </p:nvSpPr>
@@ -5802,7 +6346,7 @@
       </p:sp>
       <p:sp>
         <p:nvSpPr>
-          <p:cNvPr id="21" name="Text 19"/>
+          <p:cNvPr id="22" name="Text 20"/>
           <p:cNvSpPr txBox="1"/>
           <p:nvPr/>
         </p:nvSpPr>
@@ -5844,7 +6388,7 @@
       </p:sp>
       <p:sp>
         <p:nvSpPr>
-          <p:cNvPr id="22" name="Text 20"/>
+          <p:cNvPr id="23" name="Text 21"/>
           <p:cNvSpPr txBox="1"/>
           <p:nvPr/>
         </p:nvSpPr>
@@ -5878,7 +6422,7 @@
                 <a:ea typeface="Calibri" pitchFamily="34" charset="-122"/>
                 <a:cs typeface="Calibri" pitchFamily="34" charset="-120"/>
               </a:rPr>
-              <a:t>Allow it inside the rules. Hold big spends for the owner's "haan". Refuse with the exact fix.</a:t>
+              <a:t>Allow it inside the rules. Hold big spends until the owner taps "Haan". Refuse with the exact fix.</a:t>
             </a:r>
             <a:endParaRPr lang="en-US" sz="1300" dirty="0"/>
           </a:p>
@@ -5886,7 +6430,7 @@
       </p:sp>
       <p:sp>
         <p:nvSpPr>
-          <p:cNvPr id="23" name="Shape 21"/>
+          <p:cNvPr id="24" name="Shape 22"/>
           <p:cNvSpPr/>
           <p:nvPr/>
         </p:nvSpPr>
@@ -5913,7 +6457,7 @@
       </p:sp>
       <p:sp>
         <p:nvSpPr>
-          <p:cNvPr id="24" name="Text 22"/>
+          <p:cNvPr id="25" name="Text 23"/>
           <p:cNvSpPr txBox="1"/>
           <p:nvPr/>
         </p:nvSpPr>
@@ -5955,7 +6499,7 @@
       </p:sp>
       <p:sp>
         <p:nvSpPr>
-          <p:cNvPr id="25" name="Shape 23"/>
+          <p:cNvPr id="26" name="Shape 24"/>
           <p:cNvSpPr/>
           <p:nvPr/>
         </p:nvSpPr>
@@ -5982,7 +6526,7 @@
       </p:sp>
       <p:sp>
         <p:nvSpPr>
-          <p:cNvPr id="26" name="Text 24"/>
+          <p:cNvPr id="27" name="Text 25"/>
           <p:cNvSpPr txBox="1"/>
           <p:nvPr/>
         </p:nvSpPr>
@@ -6024,7 +6568,7 @@
       </p:sp>
       <p:sp>
         <p:nvSpPr>
-          <p:cNvPr id="27" name="Shape 25"/>
+          <p:cNvPr id="28" name="Shape 26"/>
           <p:cNvSpPr/>
           <p:nvPr/>
         </p:nvSpPr>
@@ -6051,7 +6595,7 @@
       </p:sp>
       <p:sp>
         <p:nvSpPr>
-          <p:cNvPr id="28" name="Text 26"/>
+          <p:cNvPr id="29" name="Text 27"/>
           <p:cNvSpPr txBox="1"/>
           <p:nvPr/>
         </p:nvSpPr>
@@ -6093,7 +6637,7 @@
       </p:sp>
       <p:sp>
         <p:nvSpPr>
-          <p:cNvPr id="29" name="Shape 27"/>
+          <p:cNvPr id="30" name="Shape 28"/>
           <p:cNvSpPr/>
           <p:nvPr/>
         </p:nvSpPr>
@@ -6117,7 +6661,7 @@
       </p:sp>
       <p:sp>
         <p:nvSpPr>
-          <p:cNvPr id="30" name="Shape 28"/>
+          <p:cNvPr id="31" name="Shape 29"/>
           <p:cNvSpPr/>
           <p:nvPr/>
         </p:nvSpPr>
@@ -6144,7 +6688,7 @@
       </p:sp>
       <p:sp>
         <p:nvSpPr>
-          <p:cNvPr id="31" name="Shape 29"/>
+          <p:cNvPr id="32" name="Shape 30"/>
           <p:cNvSpPr/>
           <p:nvPr/>
         </p:nvSpPr>
@@ -6169,7 +6713,7 @@
       </p:sp>
       <p:sp>
         <p:nvSpPr>
-          <p:cNvPr id="32" name="Text 30"/>
+          <p:cNvPr id="33" name="Text 31"/>
           <p:cNvSpPr txBox="1"/>
           <p:nvPr/>
         </p:nvSpPr>
@@ -6211,7 +6755,7 @@
       </p:sp>
       <p:sp>
         <p:nvSpPr>
-          <p:cNvPr id="33" name="Text 31"/>
+          <p:cNvPr id="34" name="Text 32"/>
           <p:cNvSpPr txBox="1"/>
           <p:nvPr/>
         </p:nvSpPr>
@@ -6253,7 +6797,7 @@
       </p:sp>
       <p:sp>
         <p:nvSpPr>
-          <p:cNvPr id="34" name="Text 32"/>
+          <p:cNvPr id="35" name="Text 33"/>
           <p:cNvSpPr txBox="1"/>
           <p:nvPr/>
         </p:nvSpPr>
@@ -6287,7 +6831,7 @@
                 <a:ea typeface="Calibri" pitchFamily="34" charset="-122"/>
                 <a:cs typeface="Calibri" pitchFamily="34" charset="-120"/>
               </a:rPr>
-              <a:t>A signed, single-use passport releases the offer. 20% of customers are held back to compare.</a:t>
+              <a:t>A signed, single-use passport releases it. 1 in 5 customers don't get it for 14 days, so we can tell if it worked.</a:t>
             </a:r>
             <a:endParaRPr lang="en-US" sz="1300" dirty="0"/>
           </a:p>
@@ -6295,7 +6839,7 @@
       </p:sp>
       <p:sp>
         <p:nvSpPr>
-          <p:cNvPr id="35" name="Shape 33"/>
+          <p:cNvPr id="36" name="Shape 34"/>
           <p:cNvSpPr/>
           <p:nvPr/>
         </p:nvSpPr>
@@ -6319,7 +6863,7 @@
       </p:sp>
       <p:sp>
         <p:nvSpPr>
-          <p:cNvPr id="36" name="Shape 34"/>
+          <p:cNvPr id="37" name="Shape 35"/>
           <p:cNvSpPr/>
           <p:nvPr/>
         </p:nvSpPr>
@@ -6346,7 +6890,7 @@
       </p:sp>
       <p:sp>
         <p:nvSpPr>
-          <p:cNvPr id="37" name="Shape 35"/>
+          <p:cNvPr id="38" name="Shape 36"/>
           <p:cNvSpPr/>
           <p:nvPr/>
         </p:nvSpPr>
@@ -6371,7 +6915,7 @@
       </p:sp>
       <p:sp>
         <p:nvSpPr>
-          <p:cNvPr id="38" name="Text 36"/>
+          <p:cNvPr id="39" name="Text 37"/>
           <p:cNvSpPr txBox="1"/>
           <p:nvPr/>
         </p:nvSpPr>
@@ -6413,7 +6957,7 @@
       </p:sp>
       <p:sp>
         <p:nvSpPr>
-          <p:cNvPr id="39" name="Text 37"/>
+          <p:cNvPr id="40" name="Text 38"/>
           <p:cNvSpPr txBox="1"/>
           <p:nvPr/>
         </p:nvSpPr>
@@ -6455,7 +6999,7 @@
       </p:sp>
       <p:sp>
         <p:nvSpPr>
-          <p:cNvPr id="40" name="Text 38"/>
+          <p:cNvPr id="41" name="Text 39"/>
           <p:cNvSpPr txBox="1"/>
           <p:nvPr/>
         </p:nvSpPr>
@@ -6489,7 +7033,7 @@
                 <a:ea typeface="Calibri" pitchFamily="34" charset="-122"/>
                 <a:cs typeface="Calibri" pitchFamily="34" charset="-120"/>
               </a:rPr>
-              <a:t>On day 14, in Hinglish on the Soundbox. Kept if it pays, stopped if not, unused budget returned.</a:t>
+              <a:t>On day 14, in Hinglish on the Soundbox. Run again if it pays; if not, no rerun for 30 days. Unused budget returned.</a:t>
             </a:r>
             <a:endParaRPr lang="en-US" sz="1300" dirty="0"/>
           </a:p>
@@ -6497,7 +7041,7 @@
       </p:sp>
       <p:sp>
         <p:nvSpPr>
-          <p:cNvPr id="41" name="Shape 39"/>
+          <p:cNvPr id="42" name="Shape 40"/>
           <p:cNvSpPr/>
           <p:nvPr/>
         </p:nvSpPr>
@@ -6524,14 +7068,14 @@
       </p:sp>
       <p:sp>
         <p:nvSpPr>
-          <p:cNvPr id="42" name="Text 40"/>
+          <p:cNvPr id="43" name="Text 41"/>
           <p:cNvSpPr txBox="1"/>
           <p:nvPr/>
         </p:nvSpPr>
         <p:spPr>
           <a:xfrm>
             <a:off x="777240" y="4983480"/>
-            <a:ext cx="1828800" cy="201168"/>
+            <a:ext cx="2743200" cy="201168"/>
           </a:xfrm>
           <a:prstGeom prst="rect">
             <a:avLst/>
@@ -6566,7 +7110,7 @@
       </p:sp>
       <p:sp>
         <p:nvSpPr>
-          <p:cNvPr id="43" name="Text 41"/>
+          <p:cNvPr id="44" name="Text 42"/>
           <p:cNvSpPr txBox="1"/>
           <p:nvPr/>
         </p:nvSpPr>
@@ -6608,7 +7152,7 @@
       </p:sp>
       <p:sp>
         <p:nvSpPr>
-          <p:cNvPr id="44" name="Text 42"/>
+          <p:cNvPr id="45" name="Text 43"/>
           <p:cNvSpPr txBox="1"/>
           <p:nvPr/>
         </p:nvSpPr>
@@ -6642,7 +7186,7 @@
                 <a:ea typeface="Calibri" pitchFamily="34" charset="-122"/>
                 <a:cs typeface="Calibri" pitchFamily="34" charset="-120"/>
               </a:rPr>
-              <a:t>Kill switch in one sentence: from then on, every offer waits for the owner.</a:t>
+              <a:t>One sentence cancels running offers and holds every new one for your yes.</a:t>
             </a:r>
             <a:endParaRPr lang="en-US" sz="1100" dirty="0"/>
           </a:p>
@@ -6650,7 +7194,7 @@
       </p:sp>
       <p:sp>
         <p:nvSpPr>
-          <p:cNvPr id="45" name="Shape 43"/>
+          <p:cNvPr id="46" name="Shape 44"/>
           <p:cNvSpPr/>
           <p:nvPr/>
         </p:nvSpPr>
@@ -6677,7 +7221,7 @@
       </p:sp>
       <p:sp>
         <p:nvSpPr>
-          <p:cNvPr id="46" name="Text 44"/>
+          <p:cNvPr id="47" name="Text 45"/>
           <p:cNvSpPr txBox="1"/>
           <p:nvPr/>
         </p:nvSpPr>
@@ -6719,7 +7263,7 @@
       </p:sp>
       <p:sp>
         <p:nvSpPr>
-          <p:cNvPr id="47" name="Text 45"/>
+          <p:cNvPr id="48" name="Text 46"/>
           <p:cNvSpPr txBox="1"/>
           <p:nvPr/>
         </p:nvSpPr>
@@ -6753,7 +7297,7 @@
                 <a:ea typeface="Calibri" pitchFamily="34" charset="-122"/>
                 <a:cs typeface="Calibri" pitchFamily="34" charset="-120"/>
               </a:rPr>
-              <a:t>Every proposal, decision, approval, payout and result is hash-chained. Change one entry and every later hash breaks.</a:t>
+              <a:t>Every proposal, decision, approval, payout and result is hash-chained and sealed with Munim's key. An edit breaks the chain; a full rewrite fails the seals.</a:t>
             </a:r>
             <a:endParaRPr lang="en-US" sz="1300" dirty="0"/>
           </a:p>
@@ -6884,7 +7428,7 @@
         <p:spPr>
           <a:xfrm>
             <a:off x="548640" y="6419088"/>
-            <a:ext cx="7315200" cy="228600"/>
+            <a:ext cx="5852160" cy="228600"/>
           </a:xfrm>
           <a:prstGeom prst="rect">
             <a:avLst/>
@@ -6920,6 +7464,77 @@
       <p:sp>
         <p:nvSpPr>
           <p:cNvPr id="5" name="Text 3"/>
+          <p:cNvSpPr txBox="1"/>
+          <p:nvPr/>
+        </p:nvSpPr>
+        <p:spPr>
+          <a:xfrm>
+            <a:off x="6583680" y="6419088"/>
+            <a:ext cx="4510735" cy="228600"/>
+          </a:xfrm>
+          <a:prstGeom prst="rect">
+            <a:avLst/>
+          </a:prstGeom>
+          <a:noFill/>
+          <a:ln/>
+        </p:spPr>
+        <p:txBody>
+          <a:bodyPr wrap="square" lIns="0" tIns="0" rIns="0" bIns="0" rtlCol="0" anchor="t"/>
+          <a:lstStyle/>
+          <a:p>
+            <a:pPr algn="r" indent="0" marL="0">
+              <a:lnSpc>
+                <a:spcPct val="110000"/>
+              </a:lnSpc>
+              <a:buNone/>
+            </a:pPr>
+            <a:r>
+              <a:rPr lang="en-US" sz="900" b="1" dirty="0">
+                <a:solidFill>
+                  <a:srgbClr val="6B6B73"/>
+                </a:solidFill>
+                <a:latin typeface="Calibri" pitchFamily="34" charset="0"/>
+                <a:ea typeface="Calibri" pitchFamily="34" charset="-122"/>
+                <a:cs typeface="Calibri" pitchFamily="34" charset="-120"/>
+              </a:rPr>
+              <a:t>Live demo  </a:t>
+            </a:r>
+            <a:pPr algn="r" indent="0" marL="0">
+              <a:lnSpc>
+                <a:spcPct val="110000"/>
+              </a:lnSpc>
+              <a:buNone/>
+            </a:pPr>
+            <a:r>
+              <a:rPr lang="en-US" sz="900" u="sng" dirty="0">
+                <a:solidFill>
+                  <a:srgbClr val="8C1C2B"/>
+                </a:solidFill>
+                <a:uFill>
+                  <a:solidFill>
+                    <a:srgbClr val="8C1C2B"/>
+                  </a:solidFill>
+                </a:uFill>
+                <a:latin typeface="Calibri" pitchFamily="34" charset="0"/>
+                <a:ea typeface="Calibri" pitchFamily="34" charset="-122"/>
+                <a:cs typeface="Calibri" pitchFamily="34" charset="-120"/>
+                <a:hlinkClick r:id="rId1" invalidUrl="" action="" tgtFrame="" tooltip="https://saksham869.github.io/munim/" history="1" highlightClick="0" endSnd="0">
+                  <a:extLst>
+                    <a:ext uri="{A12FA001-AC4F-418D-AE19-62706E023703}">
+                      <ahyp:hlinkClr xmlns:ahyp="http://schemas.microsoft.com/office/drawing/2018/hyperlinkcolor" val="tx"/>
+                    </a:ext>
+                  </a:extLst>
+                </a:hlinkClick>
+              </a:rPr>
+              <a:t>saksham869.github.io/munim</a:t>
+            </a:r>
+            <a:endParaRPr lang="en-US" sz="900" dirty="0"/>
+          </a:p>
+        </p:txBody>
+      </p:sp>
+      <p:sp>
+        <p:nvSpPr>
+          <p:cNvPr id="6" name="Text 4"/>
           <p:cNvSpPr txBox="1"/>
           <p:nvPr/>
         </p:nvSpPr>
@@ -6961,7 +7576,7 @@
       </p:sp>
       <p:sp>
         <p:nvSpPr>
-          <p:cNvPr id="6" name="Shape 4"/>
+          <p:cNvPr id="7" name="Shape 5"/>
           <p:cNvSpPr/>
           <p:nvPr/>
         </p:nvSpPr>
@@ -6988,7 +7603,7 @@
       </p:sp>
       <p:sp>
         <p:nvSpPr>
-          <p:cNvPr id="7" name="Text 5"/>
+          <p:cNvPr id="8" name="Text 6"/>
           <p:cNvSpPr txBox="1"/>
           <p:nvPr/>
         </p:nvSpPr>
@@ -7030,7 +7645,7 @@
       </p:sp>
       <p:sp>
         <p:nvSpPr>
-          <p:cNvPr id="8" name="Text 6"/>
+          <p:cNvPr id="9" name="Text 7"/>
           <p:cNvSpPr txBox="1"/>
           <p:nvPr/>
         </p:nvSpPr>
@@ -7072,7 +7687,7 @@
       </p:sp>
       <p:sp>
         <p:nvSpPr>
-          <p:cNvPr id="9" name="Shape 7"/>
+          <p:cNvPr id="10" name="Shape 8"/>
           <p:cNvSpPr/>
           <p:nvPr/>
         </p:nvSpPr>
@@ -7099,7 +7714,7 @@
       </p:sp>
       <p:sp>
         <p:nvSpPr>
-          <p:cNvPr id="10" name="Text 8"/>
+          <p:cNvPr id="11" name="Text 9"/>
           <p:cNvSpPr txBox="1"/>
           <p:nvPr/>
         </p:nvSpPr>
@@ -7141,7 +7756,7 @@
       </p:sp>
       <p:sp>
         <p:nvSpPr>
-          <p:cNvPr id="11" name="Text 9"/>
+          <p:cNvPr id="12" name="Text 10"/>
           <p:cNvSpPr txBox="1"/>
           <p:nvPr/>
         </p:nvSpPr>
@@ -7183,7 +7798,7 @@
       </p:sp>
       <p:sp>
         <p:nvSpPr>
-          <p:cNvPr id="12" name="Shape 10"/>
+          <p:cNvPr id="13" name="Shape 11"/>
           <p:cNvSpPr/>
           <p:nvPr/>
         </p:nvSpPr>
@@ -7207,7 +7822,7 @@
       </p:sp>
       <p:sp>
         <p:nvSpPr>
-          <p:cNvPr id="13" name="Shape 11"/>
+          <p:cNvPr id="14" name="Shape 12"/>
           <p:cNvSpPr/>
           <p:nvPr/>
         </p:nvSpPr>
@@ -7234,7 +7849,7 @@
       </p:sp>
       <p:sp>
         <p:nvSpPr>
-          <p:cNvPr id="14" name="Text 12"/>
+          <p:cNvPr id="15" name="Text 13"/>
           <p:cNvSpPr txBox="1"/>
           <p:nvPr/>
         </p:nvSpPr>
@@ -7276,7 +7891,7 @@
       </p:sp>
       <p:sp>
         <p:nvSpPr>
-          <p:cNvPr id="15" name="Text 13"/>
+          <p:cNvPr id="16" name="Text 14"/>
           <p:cNvSpPr txBox="1"/>
           <p:nvPr/>
         </p:nvSpPr>
@@ -7310,7 +7925,7 @@
                 <a:ea typeface="Calibri" pitchFamily="34" charset="-122"/>
                 <a:cs typeface="Calibri" pitchFamily="34" charset="-120"/>
               </a:rPr>
-              <a:t>Pi Agents or any LLM. Untrusted. Holds no money and no keys.</a:t>
+              <a:t>Any LLM today, Pi agents later. Untrusted. Holds no money and no keys.</a:t>
             </a:r>
             <a:endParaRPr lang="en-US" sz="1100" dirty="0"/>
           </a:p>
@@ -7318,7 +7933,7 @@
       </p:sp>
       <p:sp>
         <p:nvSpPr>
-          <p:cNvPr id="16" name="Shape 14"/>
+          <p:cNvPr id="17" name="Shape 15"/>
           <p:cNvSpPr/>
           <p:nvPr/>
         </p:nvSpPr>
@@ -7345,7 +7960,7 @@
       </p:sp>
       <p:sp>
         <p:nvSpPr>
-          <p:cNvPr id="17" name="Text 15"/>
+          <p:cNvPr id="18" name="Text 16"/>
           <p:cNvSpPr txBox="1"/>
           <p:nvPr/>
         </p:nvSpPr>
@@ -7387,7 +8002,7 @@
       </p:sp>
       <p:sp>
         <p:nvSpPr>
-          <p:cNvPr id="18" name="Text 16"/>
+          <p:cNvPr id="19" name="Text 17"/>
           <p:cNvSpPr txBox="1"/>
           <p:nvPr/>
         </p:nvSpPr>
@@ -7429,7 +8044,7 @@
       </p:sp>
       <p:sp>
         <p:nvSpPr>
-          <p:cNvPr id="19" name="Shape 17"/>
+          <p:cNvPr id="20" name="Shape 18"/>
           <p:cNvSpPr/>
           <p:nvPr/>
         </p:nvSpPr>
@@ -7453,7 +8068,7 @@
       </p:sp>
       <p:sp>
         <p:nvSpPr>
-          <p:cNvPr id="20" name="Shape 18"/>
+          <p:cNvPr id="21" name="Shape 19"/>
           <p:cNvSpPr/>
           <p:nvPr/>
         </p:nvSpPr>
@@ -7477,7 +8092,7 @@
       </p:sp>
       <p:sp>
         <p:nvSpPr>
-          <p:cNvPr id="21" name="Shape 19"/>
+          <p:cNvPr id="22" name="Shape 20"/>
           <p:cNvSpPr/>
           <p:nvPr/>
         </p:nvSpPr>
@@ -7501,7 +8116,7 @@
       </p:sp>
       <p:sp>
         <p:nvSpPr>
-          <p:cNvPr id="22" name="Shape 20"/>
+          <p:cNvPr id="23" name="Shape 21"/>
           <p:cNvSpPr/>
           <p:nvPr/>
         </p:nvSpPr>
@@ -7528,7 +8143,7 @@
       </p:sp>
       <p:sp>
         <p:nvSpPr>
-          <p:cNvPr id="23" name="Text 21"/>
+          <p:cNvPr id="24" name="Text 22"/>
           <p:cNvSpPr txBox="1"/>
           <p:nvPr/>
         </p:nvSpPr>
@@ -7570,7 +8185,7 @@
       </p:sp>
       <p:sp>
         <p:nvSpPr>
-          <p:cNvPr id="24" name="Shape 22"/>
+          <p:cNvPr id="25" name="Shape 23"/>
           <p:cNvSpPr/>
           <p:nvPr/>
         </p:nvSpPr>
@@ -7597,7 +8212,7 @@
       </p:sp>
       <p:sp>
         <p:nvSpPr>
-          <p:cNvPr id="25" name="Text 23"/>
+          <p:cNvPr id="26" name="Text 24"/>
           <p:cNvSpPr txBox="1"/>
           <p:nvPr/>
         </p:nvSpPr>
@@ -7639,7 +8254,7 @@
       </p:sp>
       <p:sp>
         <p:nvSpPr>
-          <p:cNvPr id="26" name="Shape 24"/>
+          <p:cNvPr id="27" name="Shape 25"/>
           <p:cNvSpPr/>
           <p:nvPr/>
         </p:nvSpPr>
@@ -7666,7 +8281,7 @@
       </p:sp>
       <p:sp>
         <p:nvSpPr>
-          <p:cNvPr id="27" name="Text 25"/>
+          <p:cNvPr id="28" name="Text 26"/>
           <p:cNvSpPr txBox="1"/>
           <p:nvPr/>
         </p:nvSpPr>
@@ -7708,7 +8323,7 @@
       </p:sp>
       <p:sp>
         <p:nvSpPr>
-          <p:cNvPr id="28" name="Shape 26"/>
+          <p:cNvPr id="29" name="Shape 27"/>
           <p:cNvSpPr/>
           <p:nvPr/>
         </p:nvSpPr>
@@ -7732,7 +8347,7 @@
       </p:sp>
       <p:sp>
         <p:nvSpPr>
-          <p:cNvPr id="29" name="Text 27"/>
+          <p:cNvPr id="30" name="Text 28"/>
           <p:cNvSpPr txBox="1"/>
           <p:nvPr/>
         </p:nvSpPr>
@@ -7774,7 +8389,7 @@
       </p:sp>
       <p:sp>
         <p:nvSpPr>
-          <p:cNvPr id="30" name="Text 28"/>
+          <p:cNvPr id="31" name="Text 29"/>
           <p:cNvSpPr txBox="1"/>
           <p:nvPr/>
         </p:nvSpPr>
@@ -7816,7 +8431,7 @@
       </p:sp>
       <p:sp>
         <p:nvSpPr>
-          <p:cNvPr id="31" name="Shape 29"/>
+          <p:cNvPr id="32" name="Shape 30"/>
           <p:cNvSpPr/>
           <p:nvPr/>
         </p:nvSpPr>
@@ -7840,7 +8455,7 @@
       </p:sp>
       <p:sp>
         <p:nvSpPr>
-          <p:cNvPr id="32" name="Shape 30"/>
+          <p:cNvPr id="33" name="Shape 31"/>
           <p:cNvSpPr/>
           <p:nvPr/>
         </p:nvSpPr>
@@ -7864,7 +8479,7 @@
       </p:sp>
       <p:sp>
         <p:nvSpPr>
-          <p:cNvPr id="33" name="Shape 31"/>
+          <p:cNvPr id="34" name="Shape 32"/>
           <p:cNvSpPr/>
           <p:nvPr/>
         </p:nvSpPr>
@@ -7888,7 +8503,7 @@
       </p:sp>
       <p:sp>
         <p:nvSpPr>
-          <p:cNvPr id="34" name="Shape 32"/>
+          <p:cNvPr id="35" name="Shape 33"/>
           <p:cNvSpPr/>
           <p:nvPr/>
         </p:nvSpPr>
@@ -7912,7 +8527,7 @@
       </p:sp>
       <p:sp>
         <p:nvSpPr>
-          <p:cNvPr id="35" name="Shape 33"/>
+          <p:cNvPr id="36" name="Shape 34"/>
           <p:cNvSpPr/>
           <p:nvPr/>
         </p:nvSpPr>
@@ -7936,7 +8551,7 @@
       </p:sp>
       <p:sp>
         <p:nvSpPr>
-          <p:cNvPr id="36" name="Shape 34"/>
+          <p:cNvPr id="37" name="Shape 35"/>
           <p:cNvSpPr/>
           <p:nvPr/>
         </p:nvSpPr>
@@ -7963,7 +8578,7 @@
       </p:sp>
       <p:sp>
         <p:nvSpPr>
-          <p:cNvPr id="37" name="Text 35"/>
+          <p:cNvPr id="38" name="Text 36"/>
           <p:cNvSpPr txBox="1"/>
           <p:nvPr/>
         </p:nvSpPr>
@@ -8005,7 +8620,7 @@
       </p:sp>
       <p:sp>
         <p:nvSpPr>
-          <p:cNvPr id="38" name="Text 36"/>
+          <p:cNvPr id="39" name="Text 37"/>
           <p:cNvSpPr txBox="1"/>
           <p:nvPr/>
         </p:nvSpPr>
@@ -8047,7 +8662,7 @@
       </p:sp>
       <p:sp>
         <p:nvSpPr>
-          <p:cNvPr id="39" name="Shape 37"/>
+          <p:cNvPr id="40" name="Shape 38"/>
           <p:cNvSpPr/>
           <p:nvPr/>
         </p:nvSpPr>
@@ -8071,7 +8686,7 @@
       </p:sp>
       <p:sp>
         <p:nvSpPr>
-          <p:cNvPr id="40" name="Shape 38"/>
+          <p:cNvPr id="41" name="Shape 39"/>
           <p:cNvSpPr/>
           <p:nvPr/>
         </p:nvSpPr>
@@ -8098,7 +8713,7 @@
       </p:sp>
       <p:sp>
         <p:nvSpPr>
-          <p:cNvPr id="41" name="Text 39"/>
+          <p:cNvPr id="42" name="Text 40"/>
           <p:cNvSpPr txBox="1"/>
           <p:nvPr/>
         </p:nvSpPr>
@@ -8140,7 +8755,7 @@
       </p:sp>
       <p:sp>
         <p:nvSpPr>
-          <p:cNvPr id="42" name="Text 40"/>
+          <p:cNvPr id="43" name="Text 41"/>
           <p:cNvSpPr txBox="1"/>
           <p:nvPr/>
         </p:nvSpPr>
@@ -8182,7 +8797,7 @@
       </p:sp>
       <p:sp>
         <p:nvSpPr>
-          <p:cNvPr id="43" name="Shape 41"/>
+          <p:cNvPr id="44" name="Shape 42"/>
           <p:cNvSpPr/>
           <p:nvPr/>
         </p:nvSpPr>
@@ -8206,7 +8821,7 @@
       </p:sp>
       <p:sp>
         <p:nvSpPr>
-          <p:cNvPr id="44" name="Shape 42"/>
+          <p:cNvPr id="45" name="Shape 43"/>
           <p:cNvSpPr/>
           <p:nvPr/>
         </p:nvSpPr>
@@ -8233,7 +8848,7 @@
       </p:sp>
       <p:sp>
         <p:nvSpPr>
-          <p:cNvPr id="45" name="Text 43"/>
+          <p:cNvPr id="46" name="Text 44"/>
           <p:cNvSpPr txBox="1"/>
           <p:nvPr/>
         </p:nvSpPr>
@@ -8275,7 +8890,7 @@
       </p:sp>
       <p:sp>
         <p:nvSpPr>
-          <p:cNvPr id="46" name="Text 44"/>
+          <p:cNvPr id="47" name="Text 45"/>
           <p:cNvSpPr txBox="1"/>
           <p:nvPr/>
         </p:nvSpPr>
@@ -8317,7 +8932,7 @@
       </p:sp>
       <p:sp>
         <p:nvSpPr>
-          <p:cNvPr id="47" name="Shape 45"/>
+          <p:cNvPr id="48" name="Shape 46"/>
           <p:cNvSpPr/>
           <p:nvPr/>
         </p:nvSpPr>
@@ -8341,7 +8956,7 @@
       </p:sp>
       <p:sp>
         <p:nvSpPr>
-          <p:cNvPr id="48" name="Shape 46"/>
+          <p:cNvPr id="49" name="Shape 47"/>
           <p:cNvSpPr/>
           <p:nvPr/>
         </p:nvSpPr>
@@ -8368,7 +8983,7 @@
       </p:sp>
       <p:sp>
         <p:nvSpPr>
-          <p:cNvPr id="49" name="Text 47"/>
+          <p:cNvPr id="50" name="Text 48"/>
           <p:cNvSpPr txBox="1"/>
           <p:nvPr/>
         </p:nvSpPr>
@@ -8410,7 +9025,7 @@
       </p:sp>
       <p:sp>
         <p:nvSpPr>
-          <p:cNvPr id="50" name="Text 48"/>
+          <p:cNvPr id="51" name="Text 49"/>
           <p:cNvSpPr txBox="1"/>
           <p:nvPr/>
         </p:nvSpPr>
@@ -8452,7 +9067,7 @@
       </p:sp>
       <p:sp>
         <p:nvSpPr>
-          <p:cNvPr id="51" name="Shape 49"/>
+          <p:cNvPr id="52" name="Shape 50"/>
           <p:cNvSpPr/>
           <p:nvPr/>
         </p:nvSpPr>
@@ -8477,7 +9092,7 @@
       </p:sp>
       <p:sp>
         <p:nvSpPr>
-          <p:cNvPr id="52" name="Text 50"/>
+          <p:cNvPr id="53" name="Text 51"/>
           <p:cNvSpPr txBox="1"/>
           <p:nvPr/>
         </p:nvSpPr>
@@ -8519,7 +9134,7 @@
       </p:sp>
       <p:sp>
         <p:nvSpPr>
-          <p:cNvPr id="53" name="Shape 51"/>
+          <p:cNvPr id="54" name="Shape 52"/>
           <p:cNvSpPr/>
           <p:nvPr/>
         </p:nvSpPr>
@@ -8546,7 +9161,7 @@
       </p:sp>
       <p:sp>
         <p:nvSpPr>
-          <p:cNvPr id="54" name="Text 52"/>
+          <p:cNvPr id="55" name="Text 53"/>
           <p:cNvSpPr txBox="1"/>
           <p:nvPr/>
         </p:nvSpPr>
@@ -8588,7 +9203,7 @@
       </p:sp>
       <p:sp>
         <p:nvSpPr>
-          <p:cNvPr id="55" name="Text 53"/>
+          <p:cNvPr id="56" name="Text 54"/>
           <p:cNvSpPr txBox="1"/>
           <p:nvPr/>
         </p:nvSpPr>
@@ -8630,7 +9245,7 @@
       </p:sp>
       <p:sp>
         <p:nvSpPr>
-          <p:cNvPr id="56" name="Text 54"/>
+          <p:cNvPr id="57" name="Text 55"/>
           <p:cNvSpPr txBox="1"/>
           <p:nvPr/>
         </p:nvSpPr>
@@ -8672,7 +9287,7 @@
       </p:sp>
       <p:sp>
         <p:nvSpPr>
-          <p:cNvPr id="57" name="Text 55"/>
+          <p:cNvPr id="58" name="Text 56"/>
           <p:cNvSpPr txBox="1"/>
           <p:nvPr/>
         </p:nvSpPr>
@@ -8714,7 +9329,7 @@
       </p:sp>
       <p:sp>
         <p:nvSpPr>
-          <p:cNvPr id="58" name="Text 56"/>
+          <p:cNvPr id="59" name="Text 57"/>
           <p:cNvSpPr txBox="1"/>
           <p:nvPr/>
         </p:nvSpPr>
@@ -8756,7 +9371,7 @@
       </p:sp>
       <p:sp>
         <p:nvSpPr>
-          <p:cNvPr id="59" name="Text 57"/>
+          <p:cNvPr id="60" name="Text 58"/>
           <p:cNvSpPr txBox="1"/>
           <p:nvPr/>
         </p:nvSpPr>
@@ -8921,7 +9536,7 @@
         <p:spPr>
           <a:xfrm>
             <a:off x="548640" y="6419088"/>
-            <a:ext cx="7315200" cy="228600"/>
+            <a:ext cx="5852160" cy="228600"/>
           </a:xfrm>
           <a:prstGeom prst="rect">
             <a:avLst/>
@@ -8957,6 +9572,77 @@
       <p:sp>
         <p:nvSpPr>
           <p:cNvPr id="5" name="Text 3"/>
+          <p:cNvSpPr txBox="1"/>
+          <p:nvPr/>
+        </p:nvSpPr>
+        <p:spPr>
+          <a:xfrm>
+            <a:off x="6583680" y="6419088"/>
+            <a:ext cx="4510735" cy="228600"/>
+          </a:xfrm>
+          <a:prstGeom prst="rect">
+            <a:avLst/>
+          </a:prstGeom>
+          <a:noFill/>
+          <a:ln/>
+        </p:spPr>
+        <p:txBody>
+          <a:bodyPr wrap="square" lIns="0" tIns="0" rIns="0" bIns="0" rtlCol="0" anchor="t"/>
+          <a:lstStyle/>
+          <a:p>
+            <a:pPr algn="r" indent="0" marL="0">
+              <a:lnSpc>
+                <a:spcPct val="110000"/>
+              </a:lnSpc>
+              <a:buNone/>
+            </a:pPr>
+            <a:r>
+              <a:rPr lang="en-US" sz="900" b="1" dirty="0">
+                <a:solidFill>
+                  <a:srgbClr val="6B6B73"/>
+                </a:solidFill>
+                <a:latin typeface="Calibri" pitchFamily="34" charset="0"/>
+                <a:ea typeface="Calibri" pitchFamily="34" charset="-122"/>
+                <a:cs typeface="Calibri" pitchFamily="34" charset="-120"/>
+              </a:rPr>
+              <a:t>Live demo  </a:t>
+            </a:r>
+            <a:pPr algn="r" indent="0" marL="0">
+              <a:lnSpc>
+                <a:spcPct val="110000"/>
+              </a:lnSpc>
+              <a:buNone/>
+            </a:pPr>
+            <a:r>
+              <a:rPr lang="en-US" sz="900" u="sng" dirty="0">
+                <a:solidFill>
+                  <a:srgbClr val="8C1C2B"/>
+                </a:solidFill>
+                <a:uFill>
+                  <a:solidFill>
+                    <a:srgbClr val="8C1C2B"/>
+                  </a:solidFill>
+                </a:uFill>
+                <a:latin typeface="Calibri" pitchFamily="34" charset="0"/>
+                <a:ea typeface="Calibri" pitchFamily="34" charset="-122"/>
+                <a:cs typeface="Calibri" pitchFamily="34" charset="-120"/>
+                <a:hlinkClick r:id="rId1" invalidUrl="" action="" tgtFrame="" tooltip="https://saksham869.github.io/munim/" history="1" highlightClick="0" endSnd="0">
+                  <a:extLst>
+                    <a:ext uri="{A12FA001-AC4F-418D-AE19-62706E023703}">
+                      <ahyp:hlinkClr xmlns:ahyp="http://schemas.microsoft.com/office/drawing/2018/hyperlinkcolor" val="tx"/>
+                    </a:ext>
+                  </a:extLst>
+                </a:hlinkClick>
+              </a:rPr>
+              <a:t>saksham869.github.io/munim</a:t>
+            </a:r>
+            <a:endParaRPr lang="en-US" sz="900" dirty="0"/>
+          </a:p>
+        </p:txBody>
+      </p:sp>
+      <p:sp>
+        <p:nvSpPr>
+          <p:cNvPr id="6" name="Text 4"/>
           <p:cNvSpPr txBox="1"/>
           <p:nvPr/>
         </p:nvSpPr>
@@ -8998,7 +9684,7 @@
       </p:sp>
       <p:sp>
         <p:nvSpPr>
-          <p:cNvPr id="6" name="Text 4"/>
+          <p:cNvPr id="7" name="Text 5"/>
           <p:cNvSpPr txBox="1"/>
           <p:nvPr/>
         </p:nvSpPr>
@@ -9040,7 +9726,7 @@
       </p:sp>
       <p:sp>
         <p:nvSpPr>
-          <p:cNvPr id="7" name="Shape 5"/>
+          <p:cNvPr id="8" name="Shape 6"/>
           <p:cNvSpPr/>
           <p:nvPr/>
         </p:nvSpPr>
@@ -9067,7 +9753,7 @@
       </p:sp>
       <p:sp>
         <p:nvSpPr>
-          <p:cNvPr id="8" name="Shape 6"/>
+          <p:cNvPr id="9" name="Shape 7"/>
           <p:cNvSpPr/>
           <p:nvPr/>
         </p:nvSpPr>
@@ -9094,7 +9780,7 @@
       </p:sp>
       <p:sp>
         <p:nvSpPr>
-          <p:cNvPr id="9" name="Text 7"/>
+          <p:cNvPr id="10" name="Text 8"/>
           <p:cNvSpPr txBox="1"/>
           <p:nvPr/>
         </p:nvSpPr>
@@ -9136,7 +9822,7 @@
       </p:sp>
       <p:sp>
         <p:nvSpPr>
-          <p:cNvPr id="10" name="Text 8"/>
+          <p:cNvPr id="11" name="Text 9"/>
           <p:cNvSpPr txBox="1"/>
           <p:nvPr/>
         </p:nvSpPr>
@@ -9178,7 +9864,7 @@
       </p:sp>
       <p:sp>
         <p:nvSpPr>
-          <p:cNvPr id="11" name="Text 9"/>
+          <p:cNvPr id="12" name="Text 10"/>
           <p:cNvSpPr txBox="1"/>
           <p:nvPr/>
         </p:nvSpPr>
@@ -9220,7 +9906,7 @@
       </p:sp>
       <p:sp>
         <p:nvSpPr>
-          <p:cNvPr id="12" name="Text 10"/>
+          <p:cNvPr id="13" name="Text 11"/>
           <p:cNvSpPr txBox="1"/>
           <p:nvPr/>
         </p:nvSpPr>
@@ -9262,7 +9948,7 @@
       </p:sp>
       <p:sp>
         <p:nvSpPr>
-          <p:cNvPr id="13" name="Shape 11"/>
+          <p:cNvPr id="14" name="Shape 12"/>
           <p:cNvSpPr/>
           <p:nvPr/>
         </p:nvSpPr>
@@ -9289,7 +9975,7 @@
       </p:sp>
       <p:sp>
         <p:nvSpPr>
-          <p:cNvPr id="14" name="Shape 12"/>
+          <p:cNvPr id="15" name="Shape 13"/>
           <p:cNvSpPr/>
           <p:nvPr/>
         </p:nvSpPr>
@@ -9316,7 +10002,7 @@
       </p:sp>
       <p:sp>
         <p:nvSpPr>
-          <p:cNvPr id="15" name="Text 13"/>
+          <p:cNvPr id="16" name="Text 14"/>
           <p:cNvSpPr txBox="1"/>
           <p:nvPr/>
         </p:nvSpPr>
@@ -9358,7 +10044,7 @@
       </p:sp>
       <p:sp>
         <p:nvSpPr>
-          <p:cNvPr id="16" name="Text 14"/>
+          <p:cNvPr id="17" name="Text 15"/>
           <p:cNvSpPr txBox="1"/>
           <p:nvPr/>
         </p:nvSpPr>
@@ -9400,7 +10086,7 @@
       </p:sp>
       <p:sp>
         <p:nvSpPr>
-          <p:cNvPr id="17" name="Text 15"/>
+          <p:cNvPr id="18" name="Text 16"/>
           <p:cNvSpPr txBox="1"/>
           <p:nvPr/>
         </p:nvSpPr>
@@ -9442,7 +10128,7 @@
       </p:sp>
       <p:sp>
         <p:nvSpPr>
-          <p:cNvPr id="18" name="Text 16"/>
+          <p:cNvPr id="19" name="Text 17"/>
           <p:cNvSpPr txBox="1"/>
           <p:nvPr/>
         </p:nvSpPr>
@@ -9476,7 +10162,7 @@
                 <a:ea typeface="Calibri" pitchFamily="34" charset="-122"/>
                 <a:cs typeface="Calibri" pitchFamily="34" charset="-120"/>
               </a:rPr>
-              <a:t>Worst case ₹480 is above the ₹300 limit. Owner says "haan"; Munim re-checks, then releases it.</a:t>
+              <a:t>Worst case ₹480 is above the ₹300 limit. Owner taps "Haan"; Munim re-checks, then releases it.</a:t>
             </a:r>
             <a:endParaRPr lang="en-US" sz="1150" dirty="0"/>
           </a:p>
@@ -9484,7 +10170,7 @@
       </p:sp>
       <p:sp>
         <p:nvSpPr>
-          <p:cNvPr id="19" name="Shape 17"/>
+          <p:cNvPr id="20" name="Shape 18"/>
           <p:cNvSpPr/>
           <p:nvPr/>
         </p:nvSpPr>
@@ -9511,7 +10197,7 @@
       </p:sp>
       <p:sp>
         <p:nvSpPr>
-          <p:cNvPr id="20" name="Shape 18"/>
+          <p:cNvPr id="21" name="Shape 19"/>
           <p:cNvSpPr/>
           <p:nvPr/>
         </p:nvSpPr>
@@ -9538,7 +10224,7 @@
       </p:sp>
       <p:sp>
         <p:nvSpPr>
-          <p:cNvPr id="21" name="Text 19"/>
+          <p:cNvPr id="22" name="Text 20"/>
           <p:cNvSpPr txBox="1"/>
           <p:nvPr/>
         </p:nvSpPr>
@@ -9580,7 +10266,7 @@
       </p:sp>
       <p:sp>
         <p:nvSpPr>
-          <p:cNvPr id="22" name="Text 20"/>
+          <p:cNvPr id="23" name="Text 21"/>
           <p:cNvSpPr txBox="1"/>
           <p:nvPr/>
         </p:nvSpPr>
@@ -9622,7 +10308,7 @@
       </p:sp>
       <p:sp>
         <p:nvSpPr>
-          <p:cNvPr id="23" name="Text 21"/>
+          <p:cNvPr id="24" name="Text 22"/>
           <p:cNvSpPr txBox="1"/>
           <p:nvPr/>
         </p:nvSpPr>
@@ -9664,7 +10350,7 @@
       </p:sp>
       <p:sp>
         <p:nvSpPr>
-          <p:cNvPr id="24" name="Text 22"/>
+          <p:cNvPr id="25" name="Text 23"/>
           <p:cNvSpPr txBox="1"/>
           <p:nvPr/>
         </p:nvSpPr>
@@ -9706,7 +10392,7 @@
       </p:sp>
       <p:sp>
         <p:nvSpPr>
-          <p:cNvPr id="25" name="Shape 23"/>
+          <p:cNvPr id="26" name="Shape 24"/>
           <p:cNvSpPr/>
           <p:nvPr/>
         </p:nvSpPr>
@@ -9733,7 +10419,7 @@
       </p:sp>
       <p:sp>
         <p:nvSpPr>
-          <p:cNvPr id="26" name="Shape 24"/>
+          <p:cNvPr id="27" name="Shape 25"/>
           <p:cNvSpPr/>
           <p:nvPr/>
         </p:nvSpPr>
@@ -9760,7 +10446,7 @@
       </p:sp>
       <p:sp>
         <p:nvSpPr>
-          <p:cNvPr id="27" name="Text 25"/>
+          <p:cNvPr id="28" name="Text 26"/>
           <p:cNvSpPr txBox="1"/>
           <p:nvPr/>
         </p:nvSpPr>
@@ -9802,7 +10488,7 @@
       </p:sp>
       <p:sp>
         <p:nvSpPr>
-          <p:cNvPr id="28" name="Text 26"/>
+          <p:cNvPr id="29" name="Text 27"/>
           <p:cNvSpPr txBox="1"/>
           <p:nvPr/>
         </p:nvSpPr>
@@ -9844,7 +10530,7 @@
       </p:sp>
       <p:sp>
         <p:nvSpPr>
-          <p:cNvPr id="29" name="Text 27"/>
+          <p:cNvPr id="30" name="Text 28"/>
           <p:cNvSpPr txBox="1"/>
           <p:nvPr/>
         </p:nvSpPr>
@@ -9886,7 +10572,7 @@
       </p:sp>
       <p:sp>
         <p:nvSpPr>
-          <p:cNvPr id="30" name="Text 28"/>
+          <p:cNvPr id="31" name="Text 29"/>
           <p:cNvSpPr txBox="1"/>
           <p:nvPr/>
         </p:nvSpPr>
@@ -9928,7 +10614,7 @@
       </p:sp>
       <p:sp>
         <p:nvSpPr>
-          <p:cNvPr id="31" name="Shape 29"/>
+          <p:cNvPr id="32" name="Shape 30"/>
           <p:cNvSpPr/>
           <p:nvPr/>
         </p:nvSpPr>
@@ -9955,7 +10641,7 @@
       </p:sp>
       <p:sp>
         <p:nvSpPr>
-          <p:cNvPr id="32" name="Shape 30"/>
+          <p:cNvPr id="33" name="Shape 31"/>
           <p:cNvSpPr/>
           <p:nvPr/>
         </p:nvSpPr>
@@ -9982,7 +10668,7 @@
       </p:sp>
       <p:sp>
         <p:nvSpPr>
-          <p:cNvPr id="33" name="Text 31"/>
+          <p:cNvPr id="34" name="Text 32"/>
           <p:cNvSpPr txBox="1"/>
           <p:nvPr/>
         </p:nvSpPr>
@@ -10024,7 +10710,7 @@
       </p:sp>
       <p:sp>
         <p:nvSpPr>
-          <p:cNvPr id="34" name="Text 32"/>
+          <p:cNvPr id="35" name="Text 33"/>
           <p:cNvSpPr txBox="1"/>
           <p:nvPr/>
         </p:nvSpPr>
@@ -10066,7 +10752,7 @@
       </p:sp>
       <p:sp>
         <p:nvSpPr>
-          <p:cNvPr id="35" name="Text 33"/>
+          <p:cNvPr id="36" name="Text 34"/>
           <p:cNvSpPr txBox="1"/>
           <p:nvPr/>
         </p:nvSpPr>
@@ -10108,7 +10794,7 @@
       </p:sp>
       <p:sp>
         <p:nvSpPr>
-          <p:cNvPr id="36" name="Text 34"/>
+          <p:cNvPr id="37" name="Text 35"/>
           <p:cNvSpPr txBox="1"/>
           <p:nvPr/>
         </p:nvSpPr>
@@ -10142,7 +10828,7 @@
                 <a:ea typeface="Calibri" pitchFamily="34" charset="-122"/>
                 <a:cs typeface="Calibri" pitchFamily="34" charset="-120"/>
               </a:rPr>
-              <a:t>₹110 spent, 12% chance it made money. Stopped automatically; ₹110 back in the budget.</a:t>
+              <a:t>₹110 spent, 12% chance it made money. Verdict: stop. The agent can't rerun it for 30 days; ₹110 back in the budget.</a:t>
             </a:r>
             <a:endParaRPr lang="en-US" sz="1150" dirty="0"/>
           </a:p>
@@ -10150,7 +10836,7 @@
       </p:sp>
       <p:sp>
         <p:nvSpPr>
-          <p:cNvPr id="37" name="Shape 35"/>
+          <p:cNvPr id="38" name="Shape 36"/>
           <p:cNvSpPr/>
           <p:nvPr/>
         </p:nvSpPr>
@@ -10177,7 +10863,7 @@
       </p:sp>
       <p:sp>
         <p:nvSpPr>
-          <p:cNvPr id="38" name="Shape 36"/>
+          <p:cNvPr id="39" name="Shape 37"/>
           <p:cNvSpPr/>
           <p:nvPr/>
         </p:nvSpPr>
@@ -10204,7 +10890,7 @@
       </p:sp>
       <p:sp>
         <p:nvSpPr>
-          <p:cNvPr id="39" name="Text 37"/>
+          <p:cNvPr id="40" name="Text 38"/>
           <p:cNvSpPr txBox="1"/>
           <p:nvPr/>
         </p:nvSpPr>
@@ -10246,7 +10932,7 @@
       </p:sp>
       <p:sp>
         <p:nvSpPr>
-          <p:cNvPr id="40" name="Text 38"/>
+          <p:cNvPr id="41" name="Text 39"/>
           <p:cNvSpPr txBox="1"/>
           <p:nvPr/>
         </p:nvSpPr>
@@ -10288,7 +10974,7 @@
       </p:sp>
       <p:sp>
         <p:nvSpPr>
-          <p:cNvPr id="41" name="Text 39"/>
+          <p:cNvPr id="42" name="Text 40"/>
           <p:cNvSpPr txBox="1"/>
           <p:nvPr/>
         </p:nvSpPr>
@@ -10330,7 +11016,7 @@
       </p:sp>
       <p:sp>
         <p:nvSpPr>
-          <p:cNvPr id="42" name="Text 40"/>
+          <p:cNvPr id="43" name="Text 41"/>
           <p:cNvSpPr txBox="1"/>
           <p:nvPr/>
         </p:nvSpPr>
@@ -10372,14 +11058,14 @@
       </p:sp>
       <p:sp>
         <p:nvSpPr>
-          <p:cNvPr id="43" name="Text 41"/>
+          <p:cNvPr id="44" name="Text 42"/>
           <p:cNvSpPr txBox="1"/>
           <p:nvPr/>
         </p:nvSpPr>
         <p:spPr>
           <a:xfrm>
             <a:off x="548640" y="5989320"/>
-            <a:ext cx="11094415" cy="274320"/>
+            <a:ext cx="6675120" cy="274320"/>
           </a:xfrm>
           <a:prstGeom prst="rect">
             <a:avLst/>
@@ -10407,6 +11093,77 @@
                 <a:cs typeface="Calibri" pitchFamily="34" charset="-120"/>
               </a:rPr>
               <a:t>Ledger: 20 entries, intact. Change one verdict and the chain breaks at entry 17.</a:t>
+            </a:r>
+            <a:endParaRPr lang="en-US" sz="1200" dirty="0"/>
+          </a:p>
+        </p:txBody>
+      </p:sp>
+      <p:sp>
+        <p:nvSpPr>
+          <p:cNvPr id="45" name="Text 43"/>
+          <p:cNvSpPr txBox="1"/>
+          <p:nvPr/>
+        </p:nvSpPr>
+        <p:spPr>
+          <a:xfrm>
+            <a:off x="7315200" y="5989320"/>
+            <a:ext cx="4327855" cy="274320"/>
+          </a:xfrm>
+          <a:prstGeom prst="rect">
+            <a:avLst/>
+          </a:prstGeom>
+          <a:noFill/>
+          <a:ln/>
+        </p:spPr>
+        <p:txBody>
+          <a:bodyPr wrap="square" lIns="0" tIns="0" rIns="0" bIns="0" rtlCol="0" anchor="t"/>
+          <a:lstStyle/>
+          <a:p>
+            <a:pPr algn="r" indent="0" marL="0">
+              <a:lnSpc>
+                <a:spcPct val="110000"/>
+              </a:lnSpc>
+              <a:buNone/>
+            </a:pPr>
+            <a:r>
+              <a:rPr lang="en-US" sz="1200" b="1" dirty="0">
+                <a:solidFill>
+                  <a:srgbClr val="1B1B1F"/>
+                </a:solidFill>
+                <a:latin typeface="Calibri" pitchFamily="34" charset="0"/>
+                <a:ea typeface="Calibri" pitchFamily="34" charset="-122"/>
+                <a:cs typeface="Calibri" pitchFamily="34" charset="-120"/>
+              </a:rPr>
+              <a:t>Replay it yourself  </a:t>
+            </a:r>
+            <a:pPr algn="r" indent="0" marL="0">
+              <a:lnSpc>
+                <a:spcPct val="110000"/>
+              </a:lnSpc>
+              <a:buNone/>
+            </a:pPr>
+            <a:r>
+              <a:rPr lang="en-US" sz="1200" u="sng" dirty="0">
+                <a:solidFill>
+                  <a:srgbClr val="8C1C2B"/>
+                </a:solidFill>
+                <a:uFill>
+                  <a:solidFill>
+                    <a:srgbClr val="8C1C2B"/>
+                  </a:solidFill>
+                </a:uFill>
+                <a:latin typeface="Calibri" pitchFamily="34" charset="0"/>
+                <a:ea typeface="Calibri" pitchFamily="34" charset="-122"/>
+                <a:cs typeface="Calibri" pitchFamily="34" charset="-120"/>
+                <a:hlinkClick r:id="rId2" invalidUrl="" action="" tgtFrame="" tooltip="https://saksham869.github.io/munim/" history="1" highlightClick="0" endSnd="0">
+                  <a:extLst>
+                    <a:ext uri="{A12FA001-AC4F-418D-AE19-62706E023703}">
+                      <ahyp:hlinkClr xmlns:ahyp="http://schemas.microsoft.com/office/drawing/2018/hyperlinkcolor" val="tx"/>
+                    </a:ext>
+                  </a:extLst>
+                </a:hlinkClick>
+              </a:rPr>
+              <a:t>saksham869.github.io/munim</a:t>
             </a:r>
             <a:endParaRPr lang="en-US" sz="1200" dirty="0"/>
           </a:p>
@@ -10522,7 +11279,7 @@
                 <a:ea typeface="Cambria" pitchFamily="34" charset="-122"/>
                 <a:cs typeface="Cambria" pitchFamily="34" charset="-120"/>
               </a:rPr>
-              <a:t>One shop is too small to measure. Paytm's network is not</a:t>
+              <a:t>A shop's comparison group is too small. A pooled one is not</a:t>
             </a:r>
             <a:endParaRPr lang="en-US" sz="3000" dirty="0"/>
           </a:p>
@@ -10537,7 +11294,7 @@
         <p:spPr>
           <a:xfrm>
             <a:off x="548640" y="6419088"/>
-            <a:ext cx="7315200" cy="228600"/>
+            <a:ext cx="5852160" cy="228600"/>
           </a:xfrm>
           <a:prstGeom prst="rect">
             <a:avLst/>
@@ -10573,6 +11330,77 @@
       <p:sp>
         <p:nvSpPr>
           <p:cNvPr id="5" name="Text 3"/>
+          <p:cNvSpPr txBox="1"/>
+          <p:nvPr/>
+        </p:nvSpPr>
+        <p:spPr>
+          <a:xfrm>
+            <a:off x="6583680" y="6419088"/>
+            <a:ext cx="4510735" cy="228600"/>
+          </a:xfrm>
+          <a:prstGeom prst="rect">
+            <a:avLst/>
+          </a:prstGeom>
+          <a:noFill/>
+          <a:ln/>
+        </p:spPr>
+        <p:txBody>
+          <a:bodyPr wrap="square" lIns="0" tIns="0" rIns="0" bIns="0" rtlCol="0" anchor="t"/>
+          <a:lstStyle/>
+          <a:p>
+            <a:pPr algn="r" indent="0" marL="0">
+              <a:lnSpc>
+                <a:spcPct val="110000"/>
+              </a:lnSpc>
+              <a:buNone/>
+            </a:pPr>
+            <a:r>
+              <a:rPr lang="en-US" sz="900" b="1" dirty="0">
+                <a:solidFill>
+                  <a:srgbClr val="6B6B73"/>
+                </a:solidFill>
+                <a:latin typeface="Calibri" pitchFamily="34" charset="0"/>
+                <a:ea typeface="Calibri" pitchFamily="34" charset="-122"/>
+                <a:cs typeface="Calibri" pitchFamily="34" charset="-120"/>
+              </a:rPr>
+              <a:t>Live demo  </a:t>
+            </a:r>
+            <a:pPr algn="r" indent="0" marL="0">
+              <a:lnSpc>
+                <a:spcPct val="110000"/>
+              </a:lnSpc>
+              <a:buNone/>
+            </a:pPr>
+            <a:r>
+              <a:rPr lang="en-US" sz="900" u="sng" dirty="0">
+                <a:solidFill>
+                  <a:srgbClr val="8C1C2B"/>
+                </a:solidFill>
+                <a:uFill>
+                  <a:solidFill>
+                    <a:srgbClr val="8C1C2B"/>
+                  </a:solidFill>
+                </a:uFill>
+                <a:latin typeface="Calibri" pitchFamily="34" charset="0"/>
+                <a:ea typeface="Calibri" pitchFamily="34" charset="-122"/>
+                <a:cs typeface="Calibri" pitchFamily="34" charset="-120"/>
+                <a:hlinkClick r:id="rId1" invalidUrl="" action="" tgtFrame="" tooltip="https://saksham869.github.io/munim/" history="1" highlightClick="0" endSnd="0">
+                  <a:extLst>
+                    <a:ext uri="{A12FA001-AC4F-418D-AE19-62706E023703}">
+                      <ahyp:hlinkClr xmlns:ahyp="http://schemas.microsoft.com/office/drawing/2018/hyperlinkcolor" val="tx"/>
+                    </a:ext>
+                  </a:extLst>
+                </a:hlinkClick>
+              </a:rPr>
+              <a:t>saksham869.github.io/munim</a:t>
+            </a:r>
+            <a:endParaRPr lang="en-US" sz="900" dirty="0"/>
+          </a:p>
+        </p:txBody>
+      </p:sp>
+      <p:sp>
+        <p:nvSpPr>
+          <p:cNvPr id="6" name="Text 4"/>
           <p:cNvSpPr txBox="1"/>
           <p:nvPr/>
         </p:nvSpPr>
@@ -10614,7 +11442,7 @@
       </p:sp>
       <p:sp>
         <p:nvSpPr>
-          <p:cNvPr id="6" name="Text 4"/>
+          <p:cNvPr id="7" name="Text 5"/>
           <p:cNvSpPr txBox="1"/>
           <p:nvPr/>
         </p:nvSpPr>
@@ -10836,7 +11664,7 @@
                           <a:ea typeface="Calibri" pitchFamily="34" charset="-122"/>
                           <a:cs typeface="Calibri" pitchFamily="34" charset="-120"/>
                         </a:rPr>
-                        <a:t>Shop's own data</a:t>
+                        <a:t>Shop's own group</a:t>
                       </a:r>
                       <a:endParaRPr lang="en-US" sz="1100" dirty="0">
                         <a:latin typeface="Calibri" charset="0"/>
@@ -11110,7 +11938,7 @@
                           <a:ea typeface="Calibri" pitchFamily="34" charset="-122"/>
                           <a:cs typeface="Calibri" pitchFamily="34" charset="-120"/>
                         </a:rPr>
-                        <a:t>Stop it (6% chance of profit) ✗</a:t>
+                        <a:t>Stop it (6% chance it paid) ✗</a:t>
                       </a:r>
                       <a:endParaRPr lang="en-US" sz="1100" dirty="0">
                         <a:latin typeface="Calibri" charset="0"/>
@@ -11178,7 +12006,7 @@
                           <a:ea typeface="Calibri" pitchFamily="34" charset="-122"/>
                           <a:cs typeface="Calibri" pitchFamily="34" charset="-120"/>
                         </a:rPr>
-                        <a:t>Keep it (93% it brings customers back) ✓</a:t>
+                        <a:t>Keep measuring (56% chance it paid) ✓</a:t>
                       </a:r>
                       <a:endParaRPr lang="en-US" sz="1100" dirty="0">
                         <a:latin typeface="Calibri" charset="0"/>
@@ -11384,7 +12212,7 @@
                           <a:ea typeface="Calibri" pitchFamily="34" charset="-122"/>
                           <a:cs typeface="Calibri" pitchFamily="34" charset="-120"/>
                         </a:rPr>
-                        <a:t>Keep it (90% chance of profit) ✗</a:t>
+                        <a:t>Keep it (90% chance it paid) ✗</a:t>
                       </a:r>
                       <a:endParaRPr lang="en-US" sz="1100" dirty="0">
                         <a:latin typeface="Calibri" charset="0"/>
@@ -11452,7 +12280,7 @@
                           <a:ea typeface="Calibri" pitchFamily="34" charset="-122"/>
                           <a:cs typeface="Calibri" pitchFamily="34" charset="-120"/>
                         </a:rPr>
-                        <a:t>Stop it (12% chance of profit) ✓</a:t>
+                        <a:t>Stop it (12% chance it paid) ✓</a:t>
                       </a:r>
                       <a:endParaRPr lang="en-US" sz="1100" dirty="0">
                         <a:latin typeface="Calibri" charset="0"/>
@@ -11510,7 +12338,7 @@
       </p:graphicFrame>
       <p:sp>
         <p:nvSpPr>
-          <p:cNvPr id="8" name="Text 5"/>
+          <p:cNvPr id="9" name="Text 6"/>
           <p:cNvSpPr txBox="1"/>
           <p:nvPr/>
         </p:nvSpPr>
@@ -11544,7 +12372,7 @@
                 <a:ea typeface="Calibri" pitchFamily="34" charset="-122"/>
                 <a:cs typeface="Calibri" pitchFamily="34" charset="-120"/>
               </a:rPr>
-              <a:t>Why: by chance 5 of 9 held-back regulars came back anyway, and 0 of 6 occasional shoppers did. A baseline pooled from similar shops absorbs that noise.</a:t>
+              <a:t>One run, picked to illustrate: by chance 5 of 9 held-back regulars came back anyway, and 0 of 6 occasional shoppers did. The 1,000-campaign test is the evidence.</a:t>
             </a:r>
             <a:endParaRPr lang="en-US" sz="1200" dirty="0"/>
           </a:p>
@@ -11552,7 +12380,7 @@
       </p:sp>
       <p:sp>
         <p:nvSpPr>
-          <p:cNvPr id="9" name="Text 6"/>
+          <p:cNvPr id="10" name="Text 7"/>
           <p:cNvSpPr txBox="1"/>
           <p:nvPr/>
         </p:nvSpPr>
@@ -11594,7 +12422,7 @@
       </p:sp>
       <p:sp>
         <p:nvSpPr>
-          <p:cNvPr id="10" name="Text 7"/>
+          <p:cNvPr id="11" name="Text 8"/>
           <p:cNvSpPr txBox="1"/>
           <p:nvPr/>
         </p:nvSpPr>
@@ -11648,7 +12476,7 @@
                 <a:ea typeface="Calibri" pitchFamily="34" charset="-122"/>
                 <a:cs typeface="Calibri" pitchFamily="34" charset="-120"/>
               </a:rPr>
-              <a:t>(shop's own data: 68%)</a:t>
+              <a:t>(shop's own group: 68%)</a:t>
             </a:r>
             <a:endParaRPr lang="en-US" sz="1150" dirty="0"/>
           </a:p>
@@ -11656,7 +12484,7 @@
       </p:sp>
       <p:sp>
         <p:nvSpPr>
-          <p:cNvPr id="11" name="Text 8"/>
+          <p:cNvPr id="12" name="Text 9"/>
           <p:cNvSpPr txBox="1"/>
           <p:nvPr/>
         </p:nvSpPr>
@@ -11698,14 +12526,14 @@
       </p:sp>
       <p:sp>
         <p:nvSpPr>
-          <p:cNvPr id="12" name="Text 9"/>
-          <p:cNvSpPr txBox="1"/>
-          <p:nvPr/>
-        </p:nvSpPr>
-        <p:spPr>
-          <a:xfrm>
-            <a:off x="5074920" y="4864608"/>
-            <a:ext cx="1600200" cy="548640"/>
+          <p:cNvPr id="13" name="Text 10"/>
+          <p:cNvSpPr txBox="1"/>
+          <p:nvPr/>
+        </p:nvSpPr>
+        <p:spPr>
+          <a:xfrm>
+            <a:off x="5074920" y="4818888"/>
+            <a:ext cx="1600200" cy="685800"/>
           </a:xfrm>
           <a:prstGeom prst="rect">
             <a:avLst/>
@@ -11732,7 +12560,7 @@
                 <a:ea typeface="Calibri" pitchFamily="34" charset="-122"/>
                 <a:cs typeface="Calibri" pitchFamily="34" charset="-120"/>
               </a:rPr>
-              <a:t>of profitable offers wrongly stopped (45%)</a:t>
+              <a:t>of profitable offers wrongly stopped (shop's own group: 45%)</a:t>
             </a:r>
             <a:endParaRPr lang="en-US" sz="1150" dirty="0"/>
           </a:p>
@@ -11740,28 +12568,28 @@
       </p:sp>
       <p:sp>
         <p:nvSpPr>
-          <p:cNvPr id="13" name="Text 10"/>
-          <p:cNvSpPr txBox="1"/>
-          <p:nvPr/>
-        </p:nvSpPr>
-        <p:spPr>
-          <a:xfrm>
-            <a:off x="548640" y="5623560"/>
-            <a:ext cx="6035040" cy="457200"/>
-          </a:xfrm>
-          <a:prstGeom prst="rect">
-            <a:avLst/>
-          </a:prstGeom>
-          <a:noFill/>
-          <a:ln/>
-        </p:spPr>
-        <p:txBody>
-          <a:bodyPr wrap="square" lIns="0" tIns="0" rIns="0" bIns="0" rtlCol="0" anchor="t"/>
-          <a:lstStyle/>
-          <a:p>
-            <a:pPr algn="l" indent="0" marL="0">
-              <a:lnSpc>
-                <a:spcPct val="110000"/>
+          <p:cNvPr id="14" name="Text 11"/>
+          <p:cNvSpPr txBox="1"/>
+          <p:nvPr/>
+        </p:nvSpPr>
+        <p:spPr>
+          <a:xfrm>
+            <a:off x="548640" y="5596128"/>
+            <a:ext cx="6035040" cy="713232"/>
+          </a:xfrm>
+          <a:prstGeom prst="rect">
+            <a:avLst/>
+          </a:prstGeom>
+          <a:noFill/>
+          <a:ln/>
+        </p:spPr>
+        <p:txBody>
+          <a:bodyPr wrap="square" lIns="0" tIns="0" rIns="0" bIns="0" rtlCol="0" anchor="t"/>
+          <a:lstStyle/>
+          <a:p>
+            <a:pPr algn="l" indent="0" marL="0">
+              <a:lnSpc>
+                <a:spcPct val="112000"/>
               </a:lnSpc>
               <a:buNone/>
             </a:pPr>
@@ -11774,7 +12602,7 @@
                 <a:ea typeface="Calibri" pitchFamily="34" charset="-122"/>
                 <a:cs typeface="Calibri" pitchFamily="34" charset="-120"/>
               </a:rPr>
-              <a:t>1,000 simulated campaigns with known truth. Honest cost: pooling keeps slightly more losing offers (25% vs 23%).</a:t>
+              <a:t>1,000 simulated campaigns with known truth; pooling also won on 5 of 5 more random seeds. Honest costs: it keeps slightly more losing offers (25% vs 23%), and a pooled rate 5 points too low (a festival fortnight, say) erases the gain, so the rate must come from recent, comparable history.</a:t>
             </a:r>
             <a:endParaRPr lang="en-US" sz="1050" dirty="0"/>
           </a:p>
@@ -11782,7 +12610,7 @@
       </p:sp>
       <p:sp>
         <p:nvSpPr>
-          <p:cNvPr id="14" name="Text 11"/>
+          <p:cNvPr id="15" name="Text 12"/>
           <p:cNvSpPr txBox="1"/>
           <p:nvPr/>
         </p:nvSpPr>
@@ -11824,7 +12652,7 @@
       </p:sp>
       <p:graphicFrame>
         <p:nvGraphicFramePr>
-          <p:cNvPr id="15" name="Chart 0" descr=""/>
+          <p:cNvPr id="16" name="Chart 0" descr=""/>
           <p:cNvGraphicFramePr/>
           <p:nvPr/>
         </p:nvGraphicFramePr>
@@ -11834,13 +12662,13 @@
         </p:xfrm>
         <a:graphic xmlns:a="http://schemas.openxmlformats.org/drawingml/2006/main">
           <a:graphicData uri="http://schemas.openxmlformats.org/drawingml/2006/chart">
-            <c:chart xmlns:c="http://schemas.openxmlformats.org/drawingml/2006/chart" r:id="rId1"/>
+            <c:chart xmlns:c="http://schemas.openxmlformats.org/drawingml/2006/chart" r:id="rId2"/>
           </a:graphicData>
         </a:graphic>
       </p:graphicFrame>
       <p:sp>
         <p:nvSpPr>
-          <p:cNvPr id="16" name="Text 12"/>
+          <p:cNvPr id="17" name="Text 13"/>
           <p:cNvSpPr txBox="1"/>
           <p:nvPr/>
         </p:nvSpPr>
@@ -11874,7 +12702,7 @@
                 <a:ea typeface="Calibri" pitchFamily="34" charset="-122"/>
                 <a:cs typeface="Calibri" pitchFamily="34" charset="-120"/>
               </a:rPr>
-              <a:t>With no measurement, a budget-holding agent loses money on average. Munim turns it positive.</a:t>
+              <a:t>The value of the keep-or-stop call on each offer's next run, when 40% of offers do nothing.</a:t>
             </a:r>
             <a:endParaRPr lang="en-US" sz="1050" dirty="0"/>
           </a:p>
@@ -12005,7 +12833,7 @@
         <p:spPr>
           <a:xfrm>
             <a:off x="548640" y="6419088"/>
-            <a:ext cx="7315200" cy="228600"/>
+            <a:ext cx="5852160" cy="228600"/>
           </a:xfrm>
           <a:prstGeom prst="rect">
             <a:avLst/>
@@ -12041,6 +12869,77 @@
       <p:sp>
         <p:nvSpPr>
           <p:cNvPr id="5" name="Text 3"/>
+          <p:cNvSpPr txBox="1"/>
+          <p:nvPr/>
+        </p:nvSpPr>
+        <p:spPr>
+          <a:xfrm>
+            <a:off x="6583680" y="6419088"/>
+            <a:ext cx="4510735" cy="228600"/>
+          </a:xfrm>
+          <a:prstGeom prst="rect">
+            <a:avLst/>
+          </a:prstGeom>
+          <a:noFill/>
+          <a:ln/>
+        </p:spPr>
+        <p:txBody>
+          <a:bodyPr wrap="square" lIns="0" tIns="0" rIns="0" bIns="0" rtlCol="0" anchor="t"/>
+          <a:lstStyle/>
+          <a:p>
+            <a:pPr algn="r" indent="0" marL="0">
+              <a:lnSpc>
+                <a:spcPct val="110000"/>
+              </a:lnSpc>
+              <a:buNone/>
+            </a:pPr>
+            <a:r>
+              <a:rPr lang="en-US" sz="900" b="1" dirty="0">
+                <a:solidFill>
+                  <a:srgbClr val="6B6B73"/>
+                </a:solidFill>
+                <a:latin typeface="Calibri" pitchFamily="34" charset="0"/>
+                <a:ea typeface="Calibri" pitchFamily="34" charset="-122"/>
+                <a:cs typeface="Calibri" pitchFamily="34" charset="-120"/>
+              </a:rPr>
+              <a:t>Live demo  </a:t>
+            </a:r>
+            <a:pPr algn="r" indent="0" marL="0">
+              <a:lnSpc>
+                <a:spcPct val="110000"/>
+              </a:lnSpc>
+              <a:buNone/>
+            </a:pPr>
+            <a:r>
+              <a:rPr lang="en-US" sz="900" u="sng" dirty="0">
+                <a:solidFill>
+                  <a:srgbClr val="8C1C2B"/>
+                </a:solidFill>
+                <a:uFill>
+                  <a:solidFill>
+                    <a:srgbClr val="8C1C2B"/>
+                  </a:solidFill>
+                </a:uFill>
+                <a:latin typeface="Calibri" pitchFamily="34" charset="0"/>
+                <a:ea typeface="Calibri" pitchFamily="34" charset="-122"/>
+                <a:cs typeface="Calibri" pitchFamily="34" charset="-120"/>
+                <a:hlinkClick r:id="rId1" invalidUrl="" action="" tgtFrame="" tooltip="https://saksham869.github.io/munim/" history="1" highlightClick="0" endSnd="0">
+                  <a:extLst>
+                    <a:ext uri="{A12FA001-AC4F-418D-AE19-62706E023703}">
+                      <ahyp:hlinkClr xmlns:ahyp="http://schemas.microsoft.com/office/drawing/2018/hyperlinkcolor" val="tx"/>
+                    </a:ext>
+                  </a:extLst>
+                </a:hlinkClick>
+              </a:rPr>
+              <a:t>saksham869.github.io/munim</a:t>
+            </a:r>
+            <a:endParaRPr lang="en-US" sz="900" dirty="0"/>
+          </a:p>
+        </p:txBody>
+      </p:sp>
+      <p:sp>
+        <p:nvSpPr>
+          <p:cNvPr id="6" name="Text 4"/>
           <p:cNvSpPr txBox="1"/>
           <p:nvPr/>
         </p:nvSpPr>
@@ -12082,7 +12981,7 @@
       </p:sp>
       <p:sp>
         <p:nvSpPr>
-          <p:cNvPr id="6" name="Shape 4"/>
+          <p:cNvPr id="7" name="Shape 5"/>
           <p:cNvSpPr/>
           <p:nvPr/>
         </p:nvSpPr>
@@ -12109,7 +13008,7 @@
       </p:sp>
       <p:sp>
         <p:nvSpPr>
-          <p:cNvPr id="7" name="Text 5"/>
+          <p:cNvPr id="8" name="Text 6"/>
           <p:cNvSpPr txBox="1"/>
           <p:nvPr/>
         </p:nvSpPr>
@@ -12151,7 +13050,7 @@
       </p:sp>
       <p:sp>
         <p:nvSpPr>
-          <p:cNvPr id="8" name="Text 6"/>
+          <p:cNvPr id="9" name="Text 7"/>
           <p:cNvSpPr txBox="1"/>
           <p:nvPr/>
         </p:nvSpPr>
@@ -12193,7 +13092,7 @@
       </p:sp>
       <p:sp>
         <p:nvSpPr>
-          <p:cNvPr id="9" name="Text 7"/>
+          <p:cNvPr id="10" name="Text 8"/>
           <p:cNvSpPr txBox="1"/>
           <p:nvPr/>
         </p:nvSpPr>
@@ -12235,7 +13134,7 @@
       </p:sp>
       <p:sp>
         <p:nvSpPr>
-          <p:cNvPr id="10" name="Text 8"/>
+          <p:cNvPr id="11" name="Text 9"/>
           <p:cNvSpPr txBox="1"/>
           <p:nvPr/>
         </p:nvSpPr>
@@ -12277,7 +13176,7 @@
       </p:sp>
       <p:sp>
         <p:nvSpPr>
-          <p:cNvPr id="11" name="Text 9"/>
+          <p:cNvPr id="12" name="Text 10"/>
           <p:cNvSpPr txBox="1"/>
           <p:nvPr/>
         </p:nvSpPr>
@@ -12319,7 +13218,7 @@
       </p:sp>
       <p:sp>
         <p:nvSpPr>
-          <p:cNvPr id="12" name="Text 10"/>
+          <p:cNvPr id="13" name="Text 11"/>
           <p:cNvSpPr txBox="1"/>
           <p:nvPr/>
         </p:nvSpPr>
@@ -12361,7 +13260,7 @@
       </p:sp>
       <p:sp>
         <p:nvSpPr>
-          <p:cNvPr id="13" name="Text 11"/>
+          <p:cNvPr id="14" name="Text 12"/>
           <p:cNvSpPr txBox="1"/>
           <p:nvPr/>
         </p:nvSpPr>
@@ -12403,7 +13302,7 @@
       </p:sp>
       <p:sp>
         <p:nvSpPr>
-          <p:cNvPr id="14" name="Text 12"/>
+          <p:cNvPr id="15" name="Text 13"/>
           <p:cNvSpPr txBox="1"/>
           <p:nvPr/>
         </p:nvSpPr>
@@ -12445,7 +13344,7 @@
       </p:sp>
       <p:sp>
         <p:nvSpPr>
-          <p:cNvPr id="15" name="Text 13"/>
+          <p:cNvPr id="16" name="Text 14"/>
           <p:cNvSpPr txBox="1"/>
           <p:nvPr/>
         </p:nvSpPr>
@@ -12487,7 +13386,7 @@
       </p:sp>
       <p:sp>
         <p:nvSpPr>
-          <p:cNvPr id="16" name="Text 14"/>
+          <p:cNvPr id="17" name="Text 15"/>
           <p:cNvSpPr txBox="1"/>
           <p:nvPr/>
         </p:nvSpPr>
@@ -12529,7 +13428,7 @@
       </p:sp>
       <p:sp>
         <p:nvSpPr>
-          <p:cNvPr id="17" name="Text 15"/>
+          <p:cNvPr id="18" name="Text 16"/>
           <p:cNvSpPr txBox="1"/>
           <p:nvPr/>
         </p:nvSpPr>
@@ -12571,7 +13470,7 @@
       </p:sp>
       <p:sp>
         <p:nvSpPr>
-          <p:cNvPr id="18" name="Text 16"/>
+          <p:cNvPr id="19" name="Text 17"/>
           <p:cNvSpPr txBox="1"/>
           <p:nvPr/>
         </p:nvSpPr>
@@ -12613,7 +13512,7 @@
       </p:sp>
       <p:sp>
         <p:nvSpPr>
-          <p:cNvPr id="19" name="Text 17"/>
+          <p:cNvPr id="20" name="Text 18"/>
           <p:cNvSpPr txBox="1"/>
           <p:nvPr/>
         </p:nvSpPr>
@@ -12647,7 +13546,7 @@
                 <a:ea typeface="Calibri" pitchFamily="34" charset="-122"/>
                 <a:cs typeface="Calibri" pitchFamily="34" charset="-120"/>
               </a:rPr>
-              <a:t>Any OpenAI-compatible endpoint (Pi Inference, Groq, OpenAI); output parsed, never trusted</a:t>
+              <a:t>Any OpenAI-compatible endpoint; output parsed strictly, never trusted</a:t>
             </a:r>
             <a:endParaRPr lang="en-US" sz="1250" dirty="0"/>
           </a:p>
@@ -12655,7 +13554,7 @@
       </p:sp>
       <p:sp>
         <p:nvSpPr>
-          <p:cNvPr id="20" name="Text 18"/>
+          <p:cNvPr id="21" name="Text 19"/>
           <p:cNvSpPr txBox="1"/>
           <p:nvPr/>
         </p:nvSpPr>
@@ -12697,7 +13596,7 @@
       </p:sp>
       <p:sp>
         <p:nvSpPr>
-          <p:cNvPr id="21" name="Text 19"/>
+          <p:cNvPr id="22" name="Text 20"/>
           <p:cNvSpPr txBox="1"/>
           <p:nvPr/>
         </p:nvSpPr>
@@ -12739,7 +13638,7 @@
       </p:sp>
       <p:sp>
         <p:nvSpPr>
-          <p:cNvPr id="22" name="Text 20"/>
+          <p:cNvPr id="23" name="Text 21"/>
           <p:cNvSpPr txBox="1"/>
           <p:nvPr/>
         </p:nvSpPr>
@@ -12781,7 +13680,7 @@
       </p:sp>
       <p:sp>
         <p:nvSpPr>
-          <p:cNvPr id="23" name="Text 21"/>
+          <p:cNvPr id="24" name="Text 22"/>
           <p:cNvSpPr txBox="1"/>
           <p:nvPr/>
         </p:nvSpPr>
@@ -12815,7 +13714,7 @@
                 <a:ea typeface="Calibri" pitchFamily="34" charset="-122"/>
                 <a:cs typeface="Calibri" pitchFamily="34" charset="-120"/>
               </a:rPr>
-              <a:t>143 automated tests (pytest)</a:t>
+              <a:t>180 automated tests (pytest)</a:t>
             </a:r>
             <a:endParaRPr lang="en-US" sz="1250" dirty="0"/>
           </a:p>
@@ -12823,7 +13722,7 @@
       </p:sp>
       <p:sp>
         <p:nvSpPr>
-          <p:cNvPr id="24" name="Shape 22"/>
+          <p:cNvPr id="25" name="Shape 23"/>
           <p:cNvSpPr/>
           <p:nvPr/>
         </p:nvSpPr>
@@ -12850,7 +13749,7 @@
       </p:sp>
       <p:sp>
         <p:nvSpPr>
-          <p:cNvPr id="25" name="Text 23"/>
+          <p:cNvPr id="26" name="Text 24"/>
           <p:cNvSpPr txBox="1"/>
           <p:nvPr/>
         </p:nvSpPr>
@@ -12892,7 +13791,7 @@
       </p:sp>
       <p:sp>
         <p:nvSpPr>
-          <p:cNvPr id="26" name="Text 24"/>
+          <p:cNvPr id="27" name="Text 25"/>
           <p:cNvSpPr txBox="1"/>
           <p:nvPr/>
         </p:nvSpPr>
@@ -12926,7 +13825,7 @@
                 <a:ea typeface="Cambria" pitchFamily="34" charset="-122"/>
                 <a:cs typeface="Cambria" pitchFamily="34" charset="-120"/>
               </a:rPr>
-              <a:t>Soundbox</a:t>
+              <a:t>AI Soundbox</a:t>
             </a:r>
             <a:endParaRPr lang="en-US" sz="1500" dirty="0"/>
           </a:p>
@@ -12934,7 +13833,7 @@
       </p:sp>
       <p:sp>
         <p:nvSpPr>
-          <p:cNvPr id="27" name="Text 25"/>
+          <p:cNvPr id="28" name="Text 26"/>
           <p:cNvSpPr txBox="1"/>
           <p:nvPr/>
         </p:nvSpPr>
@@ -12968,7 +13867,7 @@
                 <a:ea typeface="Calibri" pitchFamily="34" charset="-122"/>
                 <a:cs typeface="Calibri" pitchFamily="34" charset="-120"/>
               </a:rPr>
-              <a:t>Rules by voice, Hinglish results, "haan" to approve</a:t>
+              <a:t>Voice and touchscreen, 11 languages; the app for older boxes</a:t>
             </a:r>
             <a:endParaRPr lang="en-US" sz="1250" dirty="0"/>
           </a:p>
@@ -12976,7 +13875,7 @@
       </p:sp>
       <p:sp>
         <p:nvSpPr>
-          <p:cNvPr id="28" name="Text 26"/>
+          <p:cNvPr id="29" name="Text 27"/>
           <p:cNvSpPr txBox="1"/>
           <p:nvPr/>
         </p:nvSpPr>
@@ -13018,7 +13917,7 @@
       </p:sp>
       <p:sp>
         <p:nvSpPr>
-          <p:cNvPr id="29" name="Text 27"/>
+          <p:cNvPr id="30" name="Text 28"/>
           <p:cNvSpPr txBox="1"/>
           <p:nvPr/>
         </p:nvSpPr>
@@ -13052,7 +13951,7 @@
                 <a:ea typeface="Calibri" pitchFamily="34" charset="-122"/>
                 <a:cs typeface="Calibri" pitchFamily="34" charset="-120"/>
               </a:rPr>
-              <a:t>The proposer; Munim sits between it and the money</a:t>
+              <a:t>Today Pi suggests ad budgets; Munim checks the offers step</a:t>
             </a:r>
             <a:endParaRPr lang="en-US" sz="1250" dirty="0"/>
           </a:p>
@@ -13060,7 +13959,7 @@
       </p:sp>
       <p:sp>
         <p:nvSpPr>
-          <p:cNvPr id="30" name="Text 28"/>
+          <p:cNvPr id="31" name="Text 29"/>
           <p:cNvSpPr txBox="1"/>
           <p:nvPr/>
         </p:nvSpPr>
@@ -13102,7 +14001,7 @@
       </p:sp>
       <p:sp>
         <p:nvSpPr>
-          <p:cNvPr id="31" name="Text 29"/>
+          <p:cNvPr id="32" name="Text 30"/>
           <p:cNvSpPr txBox="1"/>
           <p:nvPr/>
         </p:nvSpPr>
@@ -13144,7 +14043,7 @@
       </p:sp>
       <p:sp>
         <p:nvSpPr>
-          <p:cNvPr id="32" name="Text 30"/>
+          <p:cNvPr id="33" name="Text 31"/>
           <p:cNvSpPr txBox="1"/>
           <p:nvPr/>
         </p:nvSpPr>
@@ -13186,7 +14085,7 @@
       </p:sp>
       <p:sp>
         <p:nvSpPr>
-          <p:cNvPr id="33" name="Text 31"/>
+          <p:cNvPr id="34" name="Text 32"/>
           <p:cNvSpPr txBox="1"/>
           <p:nvPr/>
         </p:nvSpPr>
@@ -13220,7 +14119,7 @@
                 <a:ea typeface="Calibri" pitchFamily="34" charset="-122"/>
                 <a:cs typeface="Calibri" pitchFamily="34" charset="-120"/>
               </a:rPr>
-              <a:t>Merchant-funded cashback (mock adapter in demo)</a:t>
+              <a:t>Cashback to Paytm payers who opted in (mock in demo)</a:t>
             </a:r>
             <a:endParaRPr lang="en-US" sz="1250" dirty="0"/>
           </a:p>
@@ -13228,7 +14127,7 @@
       </p:sp>
       <p:sp>
         <p:nvSpPr>
-          <p:cNvPr id="34" name="Text 32"/>
+          <p:cNvPr id="35" name="Text 33"/>
           <p:cNvSpPr txBox="1"/>
           <p:nvPr/>
         </p:nvSpPr>
@@ -13262,7 +14161,7 @@
                 <a:ea typeface="Cambria" pitchFamily="34" charset="-122"/>
                 <a:cs typeface="Cambria" pitchFamily="34" charset="-120"/>
               </a:rPr>
-              <a:t>WhatsApp</a:t>
+              <a:t>WhatsApp Business</a:t>
             </a:r>
             <a:endParaRPr lang="en-US" sz="1500" dirty="0"/>
           </a:p>
@@ -13270,7 +14169,7 @@
       </p:sp>
       <p:sp>
         <p:nvSpPr>
-          <p:cNvPr id="35" name="Text 33"/>
+          <p:cNvPr id="36" name="Text 34"/>
           <p:cNvSpPr txBox="1"/>
           <p:nvPr/>
         </p:nvSpPr>
@@ -13304,7 +14203,7 @@
                 <a:ea typeface="Calibri" pitchFamily="34" charset="-122"/>
                 <a:cs typeface="Calibri" pitchFamily="34" charset="-120"/>
               </a:rPr>
-              <a:t>Customer messages through Pi's channels</a:t>
+              <a:t>Already connected by Pi's marketing agent for leads</a:t>
             </a:r>
             <a:endParaRPr lang="en-US" sz="1250" dirty="0"/>
           </a:p>
@@ -13435,7 +14334,7 @@
         <p:spPr>
           <a:xfrm>
             <a:off x="548640" y="6419088"/>
-            <a:ext cx="7315200" cy="228600"/>
+            <a:ext cx="5852160" cy="228600"/>
           </a:xfrm>
           <a:prstGeom prst="rect">
             <a:avLst/>
@@ -13471,6 +14370,77 @@
       <p:sp>
         <p:nvSpPr>
           <p:cNvPr id="5" name="Text 3"/>
+          <p:cNvSpPr txBox="1"/>
+          <p:nvPr/>
+        </p:nvSpPr>
+        <p:spPr>
+          <a:xfrm>
+            <a:off x="6583680" y="6419088"/>
+            <a:ext cx="4510735" cy="228600"/>
+          </a:xfrm>
+          <a:prstGeom prst="rect">
+            <a:avLst/>
+          </a:prstGeom>
+          <a:noFill/>
+          <a:ln/>
+        </p:spPr>
+        <p:txBody>
+          <a:bodyPr wrap="square" lIns="0" tIns="0" rIns="0" bIns="0" rtlCol="0" anchor="t"/>
+          <a:lstStyle/>
+          <a:p>
+            <a:pPr algn="r" indent="0" marL="0">
+              <a:lnSpc>
+                <a:spcPct val="110000"/>
+              </a:lnSpc>
+              <a:buNone/>
+            </a:pPr>
+            <a:r>
+              <a:rPr lang="en-US" sz="900" b="1" dirty="0">
+                <a:solidFill>
+                  <a:srgbClr val="6B6B73"/>
+                </a:solidFill>
+                <a:latin typeface="Calibri" pitchFamily="34" charset="0"/>
+                <a:ea typeface="Calibri" pitchFamily="34" charset="-122"/>
+                <a:cs typeface="Calibri" pitchFamily="34" charset="-120"/>
+              </a:rPr>
+              <a:t>Live demo  </a:t>
+            </a:r>
+            <a:pPr algn="r" indent="0" marL="0">
+              <a:lnSpc>
+                <a:spcPct val="110000"/>
+              </a:lnSpc>
+              <a:buNone/>
+            </a:pPr>
+            <a:r>
+              <a:rPr lang="en-US" sz="900" u="sng" dirty="0">
+                <a:solidFill>
+                  <a:srgbClr val="8C1C2B"/>
+                </a:solidFill>
+                <a:uFill>
+                  <a:solidFill>
+                    <a:srgbClr val="8C1C2B"/>
+                  </a:solidFill>
+                </a:uFill>
+                <a:latin typeface="Calibri" pitchFamily="34" charset="0"/>
+                <a:ea typeface="Calibri" pitchFamily="34" charset="-122"/>
+                <a:cs typeface="Calibri" pitchFamily="34" charset="-120"/>
+                <a:hlinkClick r:id="rId1" invalidUrl="" action="" tgtFrame="" tooltip="https://saksham869.github.io/munim/" history="1" highlightClick="0" endSnd="0">
+                  <a:extLst>
+                    <a:ext uri="{A12FA001-AC4F-418D-AE19-62706E023703}">
+                      <ahyp:hlinkClr xmlns:ahyp="http://schemas.microsoft.com/office/drawing/2018/hyperlinkcolor" val="tx"/>
+                    </a:ext>
+                  </a:extLst>
+                </a:hlinkClick>
+              </a:rPr>
+              <a:t>saksham869.github.io/munim</a:t>
+            </a:r>
+            <a:endParaRPr lang="en-US" sz="900" dirty="0"/>
+          </a:p>
+        </p:txBody>
+      </p:sp>
+      <p:sp>
+        <p:nvSpPr>
+          <p:cNvPr id="6" name="Text 4"/>
           <p:cNvSpPr txBox="1"/>
           <p:nvPr/>
         </p:nvSpPr>
@@ -13512,7 +14482,7 @@
       </p:sp>
       <p:sp>
         <p:nvSpPr>
-          <p:cNvPr id="6" name="Shape 4"/>
+          <p:cNvPr id="7" name="Shape 5"/>
           <p:cNvSpPr/>
           <p:nvPr/>
         </p:nvSpPr>
@@ -13537,7 +14507,7 @@
       </p:sp>
       <p:sp>
         <p:nvSpPr>
-          <p:cNvPr id="7" name="Text 5"/>
+          <p:cNvPr id="8" name="Text 6"/>
           <p:cNvSpPr txBox="1"/>
           <p:nvPr/>
         </p:nvSpPr>
@@ -13579,7 +14549,7 @@
       </p:sp>
       <p:sp>
         <p:nvSpPr>
-          <p:cNvPr id="8" name="Text 6"/>
+          <p:cNvPr id="9" name="Text 7"/>
           <p:cNvSpPr txBox="1"/>
           <p:nvPr/>
         </p:nvSpPr>
@@ -13621,7 +14591,7 @@
       </p:sp>
       <p:sp>
         <p:nvSpPr>
-          <p:cNvPr id="9" name="Text 7"/>
+          <p:cNvPr id="10" name="Text 8"/>
           <p:cNvSpPr txBox="1"/>
           <p:nvPr/>
         </p:nvSpPr>
@@ -13655,7 +14625,7 @@
                 <a:ea typeface="Calibri" pitchFamily="34" charset="-122"/>
                 <a:cs typeface="Calibri" pitchFamily="34" charset="-120"/>
               </a:rPr>
-              <a:t>Prompt guardrails already exist. Nothing else answers: how much may this agent spend, and did it pay?</a:t>
+              <a:t>Payment controls like Google's AP2 cap amount, payee and time; Pi asks the owner to approve a budget. None checks margin, deadweight or a comparison group.</a:t>
             </a:r>
             <a:endParaRPr lang="en-US" sz="1350" dirty="0"/>
           </a:p>
@@ -13663,7 +14633,7 @@
       </p:sp>
       <p:sp>
         <p:nvSpPr>
-          <p:cNvPr id="10" name="Shape 8"/>
+          <p:cNvPr id="11" name="Shape 9"/>
           <p:cNvSpPr/>
           <p:nvPr/>
         </p:nvSpPr>
@@ -13688,7 +14658,7 @@
       </p:sp>
       <p:sp>
         <p:nvSpPr>
-          <p:cNvPr id="11" name="Text 9"/>
+          <p:cNvPr id="12" name="Text 10"/>
           <p:cNvSpPr txBox="1"/>
           <p:nvPr/>
         </p:nvSpPr>
@@ -13730,7 +14700,7 @@
       </p:sp>
       <p:sp>
         <p:nvSpPr>
-          <p:cNvPr id="12" name="Text 10"/>
+          <p:cNvPr id="13" name="Text 11"/>
           <p:cNvSpPr txBox="1"/>
           <p:nvPr/>
         </p:nvSpPr>
@@ -13772,7 +14742,7 @@
       </p:sp>
       <p:sp>
         <p:nvSpPr>
-          <p:cNvPr id="13" name="Text 11"/>
+          <p:cNvPr id="14" name="Text 12"/>
           <p:cNvSpPr txBox="1"/>
           <p:nvPr/>
         </p:nvSpPr>
@@ -13814,7 +14784,7 @@
       </p:sp>
       <p:sp>
         <p:nvSpPr>
-          <p:cNvPr id="14" name="Shape 12"/>
+          <p:cNvPr id="15" name="Shape 13"/>
           <p:cNvSpPr/>
           <p:nvPr/>
         </p:nvSpPr>
@@ -13839,7 +14809,7 @@
       </p:sp>
       <p:sp>
         <p:nvSpPr>
-          <p:cNvPr id="15" name="Text 13"/>
+          <p:cNvPr id="16" name="Text 14"/>
           <p:cNvSpPr txBox="1"/>
           <p:nvPr/>
         </p:nvSpPr>
@@ -13881,7 +14851,7 @@
       </p:sp>
       <p:sp>
         <p:nvSpPr>
-          <p:cNvPr id="16" name="Text 14"/>
+          <p:cNvPr id="17" name="Text 15"/>
           <p:cNvSpPr txBox="1"/>
           <p:nvPr/>
         </p:nvSpPr>
@@ -13923,7 +14893,7 @@
       </p:sp>
       <p:sp>
         <p:nvSpPr>
-          <p:cNvPr id="17" name="Text 15"/>
+          <p:cNvPr id="18" name="Text 16"/>
           <p:cNvSpPr txBox="1"/>
           <p:nvPr/>
         </p:nvSpPr>
@@ -13965,7 +14935,7 @@
       </p:sp>
       <p:sp>
         <p:nvSpPr>
-          <p:cNvPr id="18" name="Shape 16"/>
+          <p:cNvPr id="19" name="Shape 17"/>
           <p:cNvSpPr/>
           <p:nvPr/>
         </p:nvSpPr>
@@ -13990,7 +14960,7 @@
       </p:sp>
       <p:sp>
         <p:nvSpPr>
-          <p:cNvPr id="19" name="Text 17"/>
+          <p:cNvPr id="20" name="Text 18"/>
           <p:cNvSpPr txBox="1"/>
           <p:nvPr/>
         </p:nvSpPr>
@@ -14032,7 +15002,7 @@
       </p:sp>
       <p:sp>
         <p:nvSpPr>
-          <p:cNvPr id="20" name="Text 18"/>
+          <p:cNvPr id="21" name="Text 19"/>
           <p:cNvSpPr txBox="1"/>
           <p:nvPr/>
         </p:nvSpPr>
@@ -14066,7 +15036,7 @@
                 <a:ea typeface="Cambria" pitchFamily="34" charset="-122"/>
                 <a:cs typeface="Cambria" pitchFamily="34" charset="-120"/>
               </a:rPr>
-              <a:t>Network-powered</a:t>
+              <a:t>Pooled baselines</a:t>
             </a:r>
             <a:endParaRPr lang="en-US" sz="1700" dirty="0"/>
           </a:p>
@@ -14074,7 +15044,7 @@
       </p:sp>
       <p:sp>
         <p:nvSpPr>
-          <p:cNvPr id="21" name="Text 19"/>
+          <p:cNvPr id="22" name="Text 20"/>
           <p:cNvSpPr txBox="1"/>
           <p:nvPr/>
         </p:nvSpPr>
@@ -14108,7 +15078,7 @@
                 <a:ea typeface="Calibri" pitchFamily="34" charset="-122"/>
                 <a:cs typeface="Calibri" pitchFamily="34" charset="-120"/>
               </a:rPr>
-              <a:t>Pooled baselines turn a 30-customer campaign into a decision. Only Paytm has that network.</a:t>
+              <a:t>Turn a 30-customer campaign into a decision: the shop's own history where it has enough, similar Paytm shops where it doesn't.</a:t>
             </a:r>
             <a:endParaRPr lang="en-US" sz="1350" dirty="0"/>
           </a:p>
@@ -14116,7 +15086,7 @@
       </p:sp>
       <p:sp>
         <p:nvSpPr>
-          <p:cNvPr id="22" name="Shape 20"/>
+          <p:cNvPr id="23" name="Shape 21"/>
           <p:cNvSpPr/>
           <p:nvPr/>
         </p:nvSpPr>
@@ -14141,7 +15111,7 @@
       </p:sp>
       <p:sp>
         <p:nvSpPr>
-          <p:cNvPr id="23" name="Text 21"/>
+          <p:cNvPr id="24" name="Text 22"/>
           <p:cNvSpPr txBox="1"/>
           <p:nvPr/>
         </p:nvSpPr>
@@ -14183,7 +15153,7 @@
       </p:sp>
       <p:sp>
         <p:nvSpPr>
-          <p:cNvPr id="24" name="Text 22"/>
+          <p:cNvPr id="25" name="Text 23"/>
           <p:cNvSpPr txBox="1"/>
           <p:nvPr/>
         </p:nvSpPr>
@@ -14225,7 +15195,7 @@
       </p:sp>
       <p:sp>
         <p:nvSpPr>
-          <p:cNvPr id="25" name="Text 23"/>
+          <p:cNvPr id="26" name="Text 24"/>
           <p:cNvSpPr txBox="1"/>
           <p:nvPr/>
         </p:nvSpPr>
@@ -14267,7 +15237,7 @@
       </p:sp>
       <p:sp>
         <p:nvSpPr>
-          <p:cNvPr id="26" name="Shape 24"/>
+          <p:cNvPr id="27" name="Shape 25"/>
           <p:cNvSpPr/>
           <p:nvPr/>
         </p:nvSpPr>
@@ -14294,14 +15264,14 @@
       </p:sp>
       <p:sp>
         <p:nvSpPr>
-          <p:cNvPr id="27" name="Text 25"/>
+          <p:cNvPr id="28" name="Text 26"/>
           <p:cNvSpPr txBox="1"/>
           <p:nvPr/>
         </p:nvSpPr>
         <p:spPr>
           <a:xfrm>
             <a:off x="8229600" y="1965960"/>
-            <a:ext cx="1828800" cy="201168"/>
+            <a:ext cx="2743200" cy="201168"/>
           </a:xfrm>
           <a:prstGeom prst="rect">
             <a:avLst/>
@@ -14328,7 +15298,7 @@
                 <a:ea typeface="Calibri" pitchFamily="34" charset="-122"/>
                 <a:cs typeface="Calibri" pitchFamily="34" charset="-120"/>
               </a:rPr>
-              <a:t>SOUNDBOX</a:t>
+              <a:t>OWNER'S APP</a:t>
             </a:r>
             <a:endParaRPr lang="en-US" sz="900" dirty="0"/>
           </a:p>
@@ -14336,7 +15306,7 @@
       </p:sp>
       <p:sp>
         <p:nvSpPr>
-          <p:cNvPr id="28" name="Text 26"/>
+          <p:cNvPr id="29" name="Text 27"/>
           <p:cNvSpPr txBox="1"/>
           <p:nvPr/>
         </p:nvSpPr>
@@ -14370,7 +15340,7 @@
                 <a:ea typeface="Cambria" pitchFamily="34" charset="-122"/>
                 <a:cs typeface="Cambria" pitchFamily="34" charset="-120"/>
               </a:rPr>
-              <a:t>Agent ka offer roka, 4 kaaran. ₹100 ke bill par ₹40 cashback se har bill par 6% munafa nahi bachega. Sujhaav: ₹250+ ke bill par ₹15.</a:t>
+              <a:t>Agent ka ₹40 wala offer roka: ismein ghaata tha. ₹250+ par ₹15 wala offer aapki manzoori ke liye taiyaar.</a:t>
             </a:r>
             <a:endParaRPr lang="en-US" sz="1700" dirty="0"/>
           </a:p>
@@ -14378,7 +15348,7 @@
       </p:sp>
       <p:sp>
         <p:nvSpPr>
-          <p:cNvPr id="29" name="Text 27"/>
+          <p:cNvPr id="30" name="Text 28"/>
           <p:cNvSpPr txBox="1"/>
           <p:nvPr/>
         </p:nvSpPr>
@@ -14412,7 +15382,7 @@
                 <a:ea typeface="Calibri" pitchFamily="34" charset="-122"/>
                 <a:cs typeface="Calibri" pitchFamily="34" charset="-120"/>
               </a:rPr>
-              <a:t>Refused, 4 reasons. ₹40 back on a ₹100 bill breaks your 6% margin. Suggested: ₹15 on bills of ₹250+.</a:t>
+              <a:t>The agent's ₹40 offer was refused: it would lose money. A ₹15 offer on ₹250+ bills is ready for your OK.</a:t>
             </a:r>
             <a:endParaRPr lang="en-US" sz="1100" dirty="0"/>
           </a:p>
@@ -14420,7 +15390,7 @@
       </p:sp>
       <p:sp>
         <p:nvSpPr>
-          <p:cNvPr id="30" name="Text 28"/>
+          <p:cNvPr id="31" name="Text 29"/>
           <p:cNvSpPr txBox="1"/>
           <p:nvPr/>
         </p:nvSpPr>
@@ -14454,7 +15424,7 @@
                 <a:ea typeface="Calibri" pitchFamily="34" charset="-122"/>
                 <a:cs typeface="Calibri" pitchFamily="34" charset="-120"/>
               </a:rPr>
-              <a:t>What the owner hears when the agent overreaches.</a:t>
+              <a:t>Refusals and margins go to the app, never out loud at the counter.</a:t>
             </a:r>
             <a:endParaRPr lang="en-US" sz="1000" dirty="0"/>
           </a:p>
@@ -14585,7 +15555,7 @@
         <p:spPr>
           <a:xfrm>
             <a:off x="548640" y="6419088"/>
-            <a:ext cx="7315200" cy="228600"/>
+            <a:ext cx="5852160" cy="228600"/>
           </a:xfrm>
           <a:prstGeom prst="rect">
             <a:avLst/>
@@ -14621,6 +15591,77 @@
       <p:sp>
         <p:nvSpPr>
           <p:cNvPr id="5" name="Text 3"/>
+          <p:cNvSpPr txBox="1"/>
+          <p:nvPr/>
+        </p:nvSpPr>
+        <p:spPr>
+          <a:xfrm>
+            <a:off x="6583680" y="6419088"/>
+            <a:ext cx="4510735" cy="228600"/>
+          </a:xfrm>
+          <a:prstGeom prst="rect">
+            <a:avLst/>
+          </a:prstGeom>
+          <a:noFill/>
+          <a:ln/>
+        </p:spPr>
+        <p:txBody>
+          <a:bodyPr wrap="square" lIns="0" tIns="0" rIns="0" bIns="0" rtlCol="0" anchor="t"/>
+          <a:lstStyle/>
+          <a:p>
+            <a:pPr algn="r" indent="0" marL="0">
+              <a:lnSpc>
+                <a:spcPct val="110000"/>
+              </a:lnSpc>
+              <a:buNone/>
+            </a:pPr>
+            <a:r>
+              <a:rPr lang="en-US" sz="900" b="1" dirty="0">
+                <a:solidFill>
+                  <a:srgbClr val="6B6B73"/>
+                </a:solidFill>
+                <a:latin typeface="Calibri" pitchFamily="34" charset="0"/>
+                <a:ea typeface="Calibri" pitchFamily="34" charset="-122"/>
+                <a:cs typeface="Calibri" pitchFamily="34" charset="-120"/>
+              </a:rPr>
+              <a:t>Live demo  </a:t>
+            </a:r>
+            <a:pPr algn="r" indent="0" marL="0">
+              <a:lnSpc>
+                <a:spcPct val="110000"/>
+              </a:lnSpc>
+              <a:buNone/>
+            </a:pPr>
+            <a:r>
+              <a:rPr lang="en-US" sz="900" u="sng" dirty="0">
+                <a:solidFill>
+                  <a:srgbClr val="8C1C2B"/>
+                </a:solidFill>
+                <a:uFill>
+                  <a:solidFill>
+                    <a:srgbClr val="8C1C2B"/>
+                  </a:solidFill>
+                </a:uFill>
+                <a:latin typeface="Calibri" pitchFamily="34" charset="0"/>
+                <a:ea typeface="Calibri" pitchFamily="34" charset="-122"/>
+                <a:cs typeface="Calibri" pitchFamily="34" charset="-120"/>
+                <a:hlinkClick r:id="rId1" invalidUrl="" action="" tgtFrame="" tooltip="https://saksham869.github.io/munim/" history="1" highlightClick="0" endSnd="0">
+                  <a:extLst>
+                    <a:ext uri="{A12FA001-AC4F-418D-AE19-62706E023703}">
+                      <ahyp:hlinkClr xmlns:ahyp="http://schemas.microsoft.com/office/drawing/2018/hyperlinkcolor" val="tx"/>
+                    </a:ext>
+                  </a:extLst>
+                </a:hlinkClick>
+              </a:rPr>
+              <a:t>saksham869.github.io/munim</a:t>
+            </a:r>
+            <a:endParaRPr lang="en-US" sz="900" dirty="0"/>
+          </a:p>
+        </p:txBody>
+      </p:sp>
+      <p:sp>
+        <p:nvSpPr>
+          <p:cNvPr id="6" name="Text 4"/>
           <p:cNvSpPr txBox="1"/>
           <p:nvPr/>
         </p:nvSpPr>
@@ -14662,7 +15703,7 @@
       </p:sp>
       <p:sp>
         <p:nvSpPr>
-          <p:cNvPr id="6" name="Shape 4"/>
+          <p:cNvPr id="7" name="Shape 5"/>
           <p:cNvSpPr/>
           <p:nvPr/>
         </p:nvSpPr>
@@ -14689,7 +15730,7 @@
       </p:sp>
       <p:sp>
         <p:nvSpPr>
-          <p:cNvPr id="7" name="Text 5"/>
+          <p:cNvPr id="8" name="Text 6"/>
           <p:cNvSpPr txBox="1"/>
           <p:nvPr/>
         </p:nvSpPr>
@@ -14731,7 +15772,7 @@
       </p:sp>
       <p:sp>
         <p:nvSpPr>
-          <p:cNvPr id="8" name="Text 6"/>
+          <p:cNvPr id="9" name="Text 7"/>
           <p:cNvSpPr txBox="1"/>
           <p:nvPr/>
         </p:nvSpPr>
@@ -14773,7 +15814,7 @@
       </p:sp>
       <p:sp>
         <p:nvSpPr>
-          <p:cNvPr id="9" name="Text 7"/>
+          <p:cNvPr id="10" name="Text 8"/>
           <p:cNvSpPr txBox="1"/>
           <p:nvPr/>
         </p:nvSpPr>
@@ -14829,7 +15870,7 @@
                 <a:ea typeface="Calibri" pitchFamily="34" charset="-122"/>
                 <a:cs typeface="Calibri" pitchFamily="34" charset="-120"/>
               </a:rPr>
-              <a:t>At least 6% margin kept on every bill</a:t>
+              <a:t>At least 6% kept on a bill at your usual margin</a:t>
             </a:r>
             <a:endParaRPr lang="en-US" sz="1350" dirty="0"/>
           </a:p>
@@ -14850,7 +15891,7 @@
                 <a:ea typeface="Calibri" pitchFamily="34" charset="-122"/>
                 <a:cs typeface="Calibri" pitchFamily="34" charset="-120"/>
               </a:rPr>
-              <a:t>Results in plain Hindi, every two weeks</a:t>
+              <a:t>Results in Hinglish when each offer ends</a:t>
             </a:r>
             <a:endParaRPr lang="en-US" sz="1350" dirty="0"/>
           </a:p>
@@ -14879,7 +15920,7 @@
       </p:sp>
       <p:sp>
         <p:nvSpPr>
-          <p:cNvPr id="10" name="Shape 8"/>
+          <p:cNvPr id="11" name="Shape 9"/>
           <p:cNvSpPr/>
           <p:nvPr/>
         </p:nvSpPr>
@@ -14906,7 +15947,7 @@
       </p:sp>
       <p:sp>
         <p:nvSpPr>
-          <p:cNvPr id="11" name="Text 9"/>
+          <p:cNvPr id="12" name="Text 10"/>
           <p:cNvSpPr txBox="1"/>
           <p:nvPr/>
         </p:nvSpPr>
@@ -14948,7 +15989,7 @@
       </p:sp>
       <p:sp>
         <p:nvSpPr>
-          <p:cNvPr id="12" name="Text 10"/>
+          <p:cNvPr id="13" name="Text 11"/>
           <p:cNvSpPr txBox="1"/>
           <p:nvPr/>
         </p:nvSpPr>
@@ -14990,7 +16031,7 @@
       </p:sp>
       <p:sp>
         <p:nvSpPr>
-          <p:cNvPr id="13" name="Text 11"/>
+          <p:cNvPr id="14" name="Text 12"/>
           <p:cNvSpPr txBox="1"/>
           <p:nvPr/>
         </p:nvSpPr>
@@ -15025,7 +16066,7 @@
                 <a:ea typeface="Calibri" pitchFamily="34" charset="-122"/>
                 <a:cs typeface="Calibri" pitchFamily="34" charset="-120"/>
               </a:rPr>
-              <a:t>Measured lift to sell Pi subscriptions</a:t>
+              <a:t>Measured lift that makes Pi Agents worth paying for</a:t>
             </a:r>
             <a:endParaRPr lang="en-US" sz="1350" dirty="0"/>
           </a:p>
@@ -15096,7 +16137,7 @@
       </p:sp>
       <p:sp>
         <p:nvSpPr>
-          <p:cNvPr id="14" name="Shape 12"/>
+          <p:cNvPr id="15" name="Shape 13"/>
           <p:cNvSpPr/>
           <p:nvPr/>
         </p:nvSpPr>
@@ -15123,7 +16164,7 @@
       </p:sp>
       <p:sp>
         <p:nvSpPr>
-          <p:cNvPr id="15" name="Text 13"/>
+          <p:cNvPr id="16" name="Text 14"/>
           <p:cNvSpPr txBox="1"/>
           <p:nvPr/>
         </p:nvSpPr>
@@ -15165,7 +16206,7 @@
       </p:sp>
       <p:sp>
         <p:nvSpPr>
-          <p:cNvPr id="16" name="Text 14"/>
+          <p:cNvPr id="17" name="Text 15"/>
           <p:cNvSpPr txBox="1"/>
           <p:nvPr/>
         </p:nvSpPr>
@@ -15207,7 +16248,7 @@
       </p:sp>
       <p:sp>
         <p:nvSpPr>
-          <p:cNvPr id="17" name="Text 15"/>
+          <p:cNvPr id="18" name="Text 16"/>
           <p:cNvSpPr txBox="1"/>
           <p:nvPr/>
         </p:nvSpPr>
@@ -15313,7 +16354,7 @@
       </p:sp>
       <p:sp>
         <p:nvSpPr>
-          <p:cNvPr id="18" name="Shape 16"/>
+          <p:cNvPr id="19" name="Shape 17"/>
           <p:cNvSpPr/>
           <p:nvPr/>
         </p:nvSpPr>
@@ -15340,14 +16381,14 @@
       </p:sp>
       <p:sp>
         <p:nvSpPr>
-          <p:cNvPr id="19" name="Text 17"/>
+          <p:cNvPr id="20" name="Text 18"/>
           <p:cNvSpPr txBox="1"/>
           <p:nvPr/>
         </p:nvSpPr>
         <p:spPr>
           <a:xfrm>
             <a:off x="822960" y="5230368"/>
-            <a:ext cx="3840480" cy="548640"/>
+            <a:ext cx="3657600" cy="548640"/>
           </a:xfrm>
           <a:prstGeom prst="rect">
             <a:avLst/>
@@ -15374,7 +16415,7 @@
                 <a:ea typeface="Cambria" pitchFamily="34" charset="-122"/>
                 <a:cs typeface="Cambria" pitchFamily="34" charset="-120"/>
               </a:rPr>
-              <a:t>-₹17.85  →  ₹15.85</a:t>
+              <a:t>₹1,280  →  ₹480</a:t>
             </a:r>
             <a:endParaRPr lang="en-US" sz="2800" dirty="0"/>
           </a:p>
@@ -15382,33 +16423,33 @@
       </p:sp>
       <p:sp>
         <p:nvSpPr>
-          <p:cNvPr id="20" name="Text 18"/>
-          <p:cNvSpPr txBox="1"/>
-          <p:nvPr/>
-        </p:nvSpPr>
-        <p:spPr>
-          <a:xfrm>
-            <a:off x="4754880" y="5239512"/>
-            <a:ext cx="6675120" cy="566928"/>
-          </a:xfrm>
-          <a:prstGeom prst="rect">
-            <a:avLst/>
-          </a:prstGeom>
-          <a:noFill/>
-          <a:ln/>
-        </p:spPr>
-        <p:txBody>
-          <a:bodyPr wrap="square" lIns="0" tIns="0" rIns="0" bIns="0" rtlCol="0" anchor="t"/>
-          <a:lstStyle/>
-          <a:p>
-            <a:pPr algn="l" indent="0" marL="0">
-              <a:lnSpc>
-                <a:spcPct val="115000"/>
-              </a:lnSpc>
-              <a:buNone/>
-            </a:pPr>
-            <a:r>
-              <a:rPr lang="en-US" sz="1300" dirty="0">
+          <p:cNvPr id="21" name="Text 19"/>
+          <p:cNvSpPr txBox="1"/>
+          <p:nvPr/>
+        </p:nvSpPr>
+        <p:spPr>
+          <a:xfrm>
+            <a:off x="4480560" y="5193792"/>
+            <a:ext cx="6949440" cy="685800"/>
+          </a:xfrm>
+          <a:prstGeom prst="rect">
+            <a:avLst/>
+          </a:prstGeom>
+          <a:noFill/>
+          <a:ln/>
+        </p:spPr>
+        <p:txBody>
+          <a:bodyPr wrap="square" lIns="0" tIns="0" rIns="0" bIns="0" rtlCol="0" anchor="t"/>
+          <a:lstStyle/>
+          <a:p>
+            <a:pPr algn="l" indent="0" marL="0">
+              <a:lnSpc>
+                <a:spcPct val="112000"/>
+              </a:lnSpc>
+              <a:buNone/>
+            </a:pPr>
+            <a:r>
+              <a:rPr lang="en-US" sz="1200" dirty="0">
                 <a:solidFill>
                   <a:srgbClr val="D7D7DC"/>
                 </a:solidFill>
@@ -15416,9 +16457,9 @@
                 <a:ea typeface="Calibri" pitchFamily="34" charset="-122"/>
                 <a:cs typeface="Calibri" pitchFamily="34" charset="-120"/>
               </a:rPr>
-              <a:t>Expected profit per campaign when an agent keeps every offer, versus when Munim measures and stops the losers (1,000 simulated campaigns).</a:t>
-            </a:r>
-            <a:endParaRPr lang="en-US" sz="1300" dirty="0"/>
+              <a:t>Worst case of the agent's first offer vs the replanned offer the owner approved; the first would lose money even if every customer came back. In simulation: ₹15.85 per campaign vs -₹17.85 keeping every offer.</a:t>
+            </a:r>
+            <a:endParaRPr lang="en-US" sz="1200" dirty="0"/>
           </a:p>
         </p:txBody>
       </p:sp>

</xml_diff>